<commit_message>
Update pptx with fast mode
Signed-off-by: azerr <azerr@redhat.com>
</commit_message>
<xml_diff>
--- a/presentation/MCP_LanguageTools.pptx
+++ b/presentation/MCP_LanguageTools.pptx
@@ -5226,7 +5226,7 @@
               </a:defRPr>
             </a:pPr>
             <a:r>
-              <a:t>Open Platform: 18 Built-in Extensions</a:t>
+              <a:t>Open Platform: 19 Built-in Extensions</a:t>
             </a:r>
           </a:p>
         </p:txBody>
@@ -5342,7 +5342,7 @@
               </a:defRPr>
             </a:pPr>
             <a:r>
-              <a:t>21 LSP servers (built-in)</a:t>
+              <a:t>22 LSP servers (built-in)</a:t>
             </a:r>
           </a:p>
         </p:txBody>
@@ -5378,15 +5378,15 @@
               </a:defRPr>
             </a:pPr>
             <a:r>
-              <a:t>Java (JDT.LS)  ·  JavaScript/TS  ·  Angular  ·  Python (Pyright)  ·  Go (gopls)</a:t>
+              <a:t>Java (JDT.LS)  ·  JavaScript/TS  ·  Angular  ·  Python (Pyright)  ·  Go (gopls)Rust (rust-analyzer)  ·  C/C++ (clangd)  ·  C# (OmniSharp)  ·  XML (LemMinX)YAML  ·  Kotlin  ·  Dart  ·  PHP  ·  Lua  ·  Dockerfile  ·  MicroProfile  ·  Quarkus  ·  Qute  ·  Liberty  ·  Jakarta</a:t>
             </a:r>
             <a:br/>
             <a:r>
-              <a:t>Rust (rust-analyzer)  ·  C/C++ (clangd)  ·  C# (OmniSharp)  ·  XML (LemMinX)</a:t>
+              <a:t/>
             </a:r>
             <a:br/>
             <a:r>
-              <a:t>YAML  ·  Kotlin  ·  Dart  ·  PHP  ·  Lua  ·  Dockerfile  ·  MicroProfile  ·  Quarkus  ·  Qute  ·  Liberty</a:t>
+              <a:t/>
             </a:r>
           </a:p>
         </p:txBody>
@@ -6336,19 +6336,19 @@
               </a:defRPr>
             </a:pPr>
             <a:r>
-              <a:t>All 21 LSP servers,</a:t>
+              <a:t>All 22 LSP servers,enable/disable, install,language filter,configuration</a:t>
             </a:r>
             <a:br/>
             <a:r>
-              <a:t>enable/disable, install,</a:t>
+              <a:t/>
             </a:r>
             <a:br/>
             <a:r>
-              <a:t>language filter,</a:t>
+              <a:t/>
             </a:r>
             <a:br/>
             <a:r>
-              <a:t>configuration</a:t>
+              <a:t/>
             </a:r>
           </a:p>
         </p:txBody>
@@ -6824,7 +6824,7 @@
               </a:defRPr>
             </a:pPr>
             <a:r>
-              <a:t>21 LSP servers — enable/disable, install, language filter, configuration</a:t>
+              <a:t>22 LSP servers — enable/disable, install, language filter, configuration</a:t>
             </a:r>
           </a:p>
         </p:txBody>
@@ -8970,7 +8970,7 @@
               </a:defRPr>
             </a:pPr>
             <a:r>
-              <a:t>Scaling to large Java projects and beyond</a:t>
+              <a:t>Scaling to large Java projects — Fast mode available</a:t>
             </a:r>
           </a:p>
         </p:txBody>
@@ -9438,6 +9438,28 @@
                 <a:latin typeface="Segoe UI"/>
               </a:rPr>
               <a:t>More language extensions</a:t>
+            </a:r>
+          </a:p>
+          <a:p>
+            <a:pPr>
+              <a:spcBef>
+                <a:spcPts val="200"/>
+              </a:spcBef>
+              <a:spcAft>
+                <a:spcPts val="600"/>
+              </a:spcAft>
+            </a:pPr>
+            <a:r>
+              <a:rPr sz="1400">
+                <a:solidFill>
+                  <a:srgbClr val="007ACC"/>
+                </a:solidFill>
+                <a:latin typeface="Segoe UI"/>
+              </a:rPr>
+              <a:t>▸ Fast mode: skip M2E for instant startup
+  → Reads pom.xml directly, resolves from ~/.m2
+  → No Maven scan, no full import
+  → ~8s (cache) vs 48s+ (M2E)</a:t>
             </a:r>
           </a:p>
         </p:txBody>
@@ -11512,7 +11534,7 @@
               </a:defRPr>
             </a:pPr>
             <a:r>
-              <a:t>110+ MCP Tools</a:t>
+              <a:t>135+ MCP Tools</a:t>
             </a:r>
           </a:p>
         </p:txBody>
@@ -11772,7 +11794,7 @@
               </a:defRPr>
             </a:pPr>
             <a:r>
-              <a:t>80 Java tools + mcp-jdtls</a:t>
+              <a:t>79 Java tools + mcp-jdtls</a:t>
             </a:r>
           </a:p>
         </p:txBody>
@@ -12172,15 +12194,15 @@
               </a:defRPr>
             </a:pPr>
             <a:r>
-              <a:t>contributes: bundles, classpath,</a:t>
+              <a:t>contributes: bundles, classpath,bindRequest/Notification79 Java tools via mcp-jdtls</a:t>
             </a:r>
             <a:br/>
             <a:r>
-              <a:t>bindRequest/Notification</a:t>
+              <a:t/>
             </a:r>
             <a:br/>
             <a:r>
-              <a:t>80 Java tools via mcp-jdtls</a:t>
+              <a:t/>
             </a:r>
           </a:p>
         </p:txBody>
@@ -12296,15 +12318,15 @@
               </a:defRPr>
             </a:pPr>
             <a:r>
-              <a:t>18+ language extensions</a:t>
+              <a:t>19+ language extensionsAdd any LSP/DAP serverAdmin console</a:t>
             </a:r>
             <a:br/>
             <a:r>
-              <a:t>Add any LSP/DAP server</a:t>
+              <a:t/>
             </a:r>
             <a:br/>
             <a:r>
-              <a:t>Admin console</a:t>
+              <a:t/>
             </a:r>
           </a:p>
         </p:txBody>
@@ -13975,7 +13997,7 @@
               </a:defRPr>
             </a:pPr>
             <a:r>
-              <a:t>Java: 80 Specialized MCP Tools</a:t>
+              <a:t>Java: 79 Specialized MCP Tools</a:t>
             </a:r>
           </a:p>
         </p:txBody>
@@ -17363,7 +17385,7 @@
               </a:defRPr>
             </a:pPr>
             <a:r>
-              <a:t>24 DAP Tools</a:t>
+              <a:t>26 DAP Tools</a:t>
             </a:r>
           </a:p>
         </p:txBody>
@@ -17639,6 +17661,44 @@
                 <a:latin typeface="Segoe UI"/>
               </a:rPr>
               <a:t>get_debug_statistics — session summary</a:t>
+            </a:r>
+          </a:p>
+          <a:p>
+            <a:pPr>
+              <a:spcBef>
+                <a:spcPts val="200"/>
+              </a:spcBef>
+              <a:spcAft>
+                <a:spcPts val="600"/>
+              </a:spcAft>
+            </a:pPr>
+            <a:r>
+              <a:rPr sz="1500">
+                <a:solidFill>
+                  <a:srgbClr val="007ACC"/>
+                </a:solidFill>
+                <a:latin typeface="Segoe UI"/>
+              </a:rPr>
+              <a:t>▸ disassemble — assembly-level inspection</a:t>
+            </a:r>
+          </a:p>
+          <a:p>
+            <a:pPr>
+              <a:spcBef>
+                <a:spcPts val="200"/>
+              </a:spcBef>
+              <a:spcAft>
+                <a:spcPts val="600"/>
+              </a:spcAft>
+            </a:pPr>
+            <a:r>
+              <a:rPr sz="1500">
+                <a:solidFill>
+                  <a:srgbClr val="007ACC"/>
+                </a:solidFill>
+                <a:latin typeface="Segoe UI"/>
+              </a:rPr>
+              <a:t>▸ set/remove_instruction_breakpoint</a:t>
             </a:r>
           </a:p>
         </p:txBody>

</xml_diff>

<commit_message>
Initialize File watcher support
Signed-off-by: azerr <azerr@redhat.com>
</commit_message>
<xml_diff>
--- a/presentation/MCP_LanguageTools.pptx
+++ b/presentation/MCP_LanguageTools.pptx
@@ -28,6 +28,7 @@
     <p:sldId id="276" r:id="rId27"/>
     <p:sldId id="277" r:id="rId28"/>
     <p:sldId id="278" r:id="rId29"/>
+    <p:sldId id="279" r:id="rId30"/>
   </p:sldIdLst>
   <p:sldSz cx="12191695" cy="6858000" type="screen4x3"/>
   <p:notesSz cx="6858000" cy="9144000"/>
@@ -5226,7 +5227,7 @@
               </a:defRPr>
             </a:pPr>
             <a:r>
-              <a:t>Open Platform: 19 Built-in Extensions</a:t>
+              <a:t>Open Platform: 18 Built-in Extensions</a:t>
             </a:r>
           </a:p>
         </p:txBody>
@@ -5342,7 +5343,7 @@
               </a:defRPr>
             </a:pPr>
             <a:r>
-              <a:t>22 LSP servers (built-in)</a:t>
+              <a:t>21 LSP servers (built-in)</a:t>
             </a:r>
           </a:p>
         </p:txBody>
@@ -5378,15 +5379,15 @@
               </a:defRPr>
             </a:pPr>
             <a:r>
-              <a:t>Java (JDT.LS)  ·  JavaScript/TS  ·  Angular  ·  Python (Pyright)  ·  Go (gopls)Rust (rust-analyzer)  ·  C/C++ (clangd)  ·  C# (OmniSharp)  ·  XML (LemMinX)YAML  ·  Kotlin  ·  Dart  ·  PHP  ·  Lua  ·  Dockerfile  ·  MicroProfile  ·  Quarkus  ·  Qute  ·  Liberty  ·  Jakarta</a:t>
+              <a:t>Java (JDT.LS)  ·  JavaScript/TS  ·  Angular  ·  Python (Pyright)  ·  Go (gopls)</a:t>
             </a:r>
             <a:br/>
             <a:r>
-              <a:t/>
+              <a:t>Rust (rust-analyzer)  ·  C/C++ (clangd)  ·  C# (OmniSharp)  ·  XML (LemMinX)</a:t>
             </a:r>
             <a:br/>
             <a:r>
-              <a:t/>
+              <a:t>YAML  ·  Kotlin  ·  Dart  ·  PHP  ·  Lua  ·  Dockerfile  ·  MicroProfile  ·  Quarkus  ·  Qute  ·  Liberty</a:t>
             </a:r>
           </a:p>
         </p:txBody>
@@ -6336,19 +6337,19 @@
               </a:defRPr>
             </a:pPr>
             <a:r>
-              <a:t>All 22 LSP servers,enable/disable, install,language filter,configuration</a:t>
+              <a:t>All 21 LSP servers,</a:t>
             </a:r>
             <a:br/>
             <a:r>
-              <a:t/>
+              <a:t>enable/disable, install,</a:t>
             </a:r>
             <a:br/>
             <a:r>
-              <a:t/>
+              <a:t>language filter,</a:t>
             </a:r>
             <a:br/>
             <a:r>
-              <a:t/>
+              <a:t>configuration</a:t>
             </a:r>
           </a:p>
         </p:txBody>
@@ -6824,7 +6825,7 @@
               </a:defRPr>
             </a:pPr>
             <a:r>
-              <a:t>22 LSP servers — enable/disable, install, language filter, configuration</a:t>
+              <a:t>21 LSP servers — enable/disable, install, language filter, configuration</a:t>
             </a:r>
           </a:p>
         </p:txBody>
@@ -8934,7 +8935,7 @@
               </a:defRPr>
             </a:pPr>
             <a:r>
-              <a:t>Roadmap</a:t>
+              <a:t>File Watcher: Keeping Language Servers in Sync</a:t>
             </a:r>
           </a:p>
         </p:txBody>
@@ -8970,7 +8971,7 @@
               </a:defRPr>
             </a:pPr>
             <a:r>
-              <a:t>Scaling to large Java projects — Fast mode available</a:t>
+              <a:t>When an AI agent creates files, language servers must know about them</a:t>
             </a:r>
           </a:p>
         </p:txBody>
@@ -8984,7 +8985,461 @@
         <p:spPr>
           <a:xfrm>
             <a:off x="731520" y="2011680"/>
-            <a:ext cx="5029200" cy="4389120"/>
+            <a:ext cx="5029200" cy="1828800"/>
+          </a:xfrm>
+          <a:prstGeom prst="roundRect">
+            <a:avLst/>
+          </a:prstGeom>
+          <a:solidFill>
+            <a:srgbClr val="3A1A1A"/>
+          </a:solidFill>
+          <a:ln>
+            <a:noFill/>
+          </a:ln>
+          <a:effectLst/>
+        </p:spPr>
+        <p:style>
+          <a:lnRef idx="1">
+            <a:schemeClr val="accent1"/>
+          </a:lnRef>
+          <a:fillRef idx="3">
+            <a:schemeClr val="accent1"/>
+          </a:fillRef>
+          <a:effectRef idx="2">
+            <a:schemeClr val="accent1"/>
+          </a:effectRef>
+          <a:fontRef idx="minor">
+            <a:schemeClr val="lt1"/>
+          </a:fontRef>
+        </p:style>
+        <p:txBody>
+          <a:bodyPr rtlCol="0" anchor="ctr"/>
+          <a:lstStyle/>
+          <a:p>
+            <a:pPr algn="ctr"/>
+          </a:p>
+        </p:txBody>
+      </p:sp>
+      <p:sp>
+        <p:nvSpPr>
+          <p:cNvPr id="6" name="TextBox 5"/>
+          <p:cNvSpPr txBox="1"/>
+          <p:nvPr/>
+        </p:nvSpPr>
+        <p:spPr>
+          <a:xfrm>
+            <a:off x="1097280" y="2103120"/>
+            <a:ext cx="4572000" cy="365760"/>
+          </a:xfrm>
+          <a:prstGeom prst="rect">
+            <a:avLst/>
+          </a:prstGeom>
+          <a:noFill/>
+        </p:spPr>
+        <p:txBody>
+          <a:bodyPr wrap="square">
+            <a:spAutoFit/>
+          </a:bodyPr>
+          <a:lstStyle/>
+          <a:p>
+            <a:pPr algn="l">
+              <a:defRPr sz="1800" b="1">
+                <a:solidFill>
+                  <a:srgbClr val="FF6B6B"/>
+                </a:solidFill>
+                <a:latin typeface="Segoe UI"/>
+              </a:defRPr>
+            </a:pPr>
+            <a:r>
+              <a:t>The Problem</a:t>
+            </a:r>
+          </a:p>
+        </p:txBody>
+      </p:sp>
+      <p:sp>
+        <p:nvSpPr>
+          <p:cNvPr id="7" name="TextBox 6"/>
+          <p:cNvSpPr txBox="1"/>
+          <p:nvPr/>
+        </p:nvSpPr>
+        <p:spPr>
+          <a:xfrm>
+            <a:off x="1097280" y="2560320"/>
+            <a:ext cx="4572000" cy="1188720"/>
+          </a:xfrm>
+          <a:prstGeom prst="rect">
+            <a:avLst/>
+          </a:prstGeom>
+          <a:noFill/>
+        </p:spPr>
+        <p:txBody>
+          <a:bodyPr wrap="square">
+            <a:spAutoFit/>
+          </a:bodyPr>
+          <a:lstStyle/>
+          <a:p>
+            <a:pPr>
+              <a:spcBef>
+                <a:spcPts val="200"/>
+              </a:spcBef>
+              <a:spcAft>
+                <a:spcPts val="600"/>
+              </a:spcAft>
+            </a:pPr>
+            <a:r>
+              <a:rPr sz="1400">
+                <a:solidFill>
+                  <a:srgbClr val="FF6B6B"/>
+                </a:solidFill>
+                <a:latin typeface="Segoe UI"/>
+              </a:rPr>
+              <a:t>▸ </a:t>
+            </a:r>
+            <a:r>
+              <a:rPr sz="1400">
+                <a:solidFill>
+                  <a:srgbClr val="E0E0E0"/>
+                </a:solidFill>
+                <a:latin typeface="Segoe UI"/>
+              </a:rPr>
+              <a:t>AI agent creates Java file on disk</a:t>
+            </a:r>
+          </a:p>
+          <a:p>
+            <a:pPr>
+              <a:spcBef>
+                <a:spcPts val="200"/>
+              </a:spcBef>
+              <a:spcAft>
+                <a:spcPts val="600"/>
+              </a:spcAft>
+            </a:pPr>
+            <a:r>
+              <a:rPr sz="1400">
+                <a:solidFill>
+                  <a:srgbClr val="FF6B6B"/>
+                </a:solidFill>
+                <a:latin typeface="Segoe UI"/>
+              </a:rPr>
+              <a:t>▸ </a:t>
+            </a:r>
+            <a:r>
+              <a:rPr sz="1400">
+                <a:solidFill>
+                  <a:srgbClr val="E0E0E0"/>
+                </a:solidFill>
+                <a:latin typeface="Segoe UI"/>
+              </a:rPr>
+              <a:t>JDT.LS doesn't know about it → ClassNotFoundException</a:t>
+            </a:r>
+          </a:p>
+          <a:p>
+            <a:pPr>
+              <a:spcBef>
+                <a:spcPts val="200"/>
+              </a:spcBef>
+              <a:spcAft>
+                <a:spcPts val="600"/>
+              </a:spcAft>
+            </a:pPr>
+            <a:r>
+              <a:rPr sz="1400">
+                <a:solidFill>
+                  <a:srgbClr val="FF6B6B"/>
+                </a:solidFill>
+                <a:latin typeface="Segoe UI"/>
+              </a:rPr>
+              <a:t>▸ </a:t>
+            </a:r>
+            <a:r>
+              <a:rPr sz="1400">
+                <a:solidFill>
+                  <a:srgbClr val="E0E0E0"/>
+                </a:solidFill>
+                <a:latin typeface="Segoe UI"/>
+              </a:rPr>
+              <a:t>Root cause: workspace/didChangeWatchedFiles was not implemented</a:t>
+            </a:r>
+          </a:p>
+        </p:txBody>
+      </p:sp>
+      <p:sp>
+        <p:nvSpPr>
+          <p:cNvPr id="8" name="Rounded Rectangle 7"/>
+          <p:cNvSpPr/>
+          <p:nvPr/>
+        </p:nvSpPr>
+        <p:spPr>
+          <a:xfrm>
+            <a:off x="6400800" y="2011680"/>
+            <a:ext cx="5029200" cy="1828800"/>
+          </a:xfrm>
+          <a:prstGeom prst="roundRect">
+            <a:avLst/>
+          </a:prstGeom>
+          <a:solidFill>
+            <a:srgbClr val="1A3A1A"/>
+          </a:solidFill>
+          <a:ln>
+            <a:noFill/>
+          </a:ln>
+          <a:effectLst/>
+        </p:spPr>
+        <p:style>
+          <a:lnRef idx="1">
+            <a:schemeClr val="accent1"/>
+          </a:lnRef>
+          <a:fillRef idx="3">
+            <a:schemeClr val="accent1"/>
+          </a:fillRef>
+          <a:effectRef idx="2">
+            <a:schemeClr val="accent1"/>
+          </a:effectRef>
+          <a:fontRef idx="minor">
+            <a:schemeClr val="lt1"/>
+          </a:fontRef>
+        </p:style>
+        <p:txBody>
+          <a:bodyPr rtlCol="0" anchor="ctr"/>
+          <a:lstStyle/>
+          <a:p>
+            <a:pPr algn="ctr"/>
+          </a:p>
+        </p:txBody>
+      </p:sp>
+      <p:sp>
+        <p:nvSpPr>
+          <p:cNvPr id="9" name="TextBox 8"/>
+          <p:cNvSpPr txBox="1"/>
+          <p:nvPr/>
+        </p:nvSpPr>
+        <p:spPr>
+          <a:xfrm>
+            <a:off x="6766560" y="2103120"/>
+            <a:ext cx="4572000" cy="365760"/>
+          </a:xfrm>
+          <a:prstGeom prst="rect">
+            <a:avLst/>
+          </a:prstGeom>
+          <a:noFill/>
+        </p:spPr>
+        <p:txBody>
+          <a:bodyPr wrap="square">
+            <a:spAutoFit/>
+          </a:bodyPr>
+          <a:lstStyle/>
+          <a:p>
+            <a:pPr algn="l">
+              <a:defRPr sz="1800" b="1">
+                <a:solidFill>
+                  <a:srgbClr val="4EC9B0"/>
+                </a:solidFill>
+                <a:latin typeface="Segoe UI"/>
+              </a:defRPr>
+            </a:pPr>
+            <a:r>
+              <a:t>The Solution: 3 Mechanisms</a:t>
+            </a:r>
+          </a:p>
+        </p:txBody>
+      </p:sp>
+      <p:sp>
+        <p:nvSpPr>
+          <p:cNvPr id="10" name="TextBox 9"/>
+          <p:cNvSpPr txBox="1"/>
+          <p:nvPr/>
+        </p:nvSpPr>
+        <p:spPr>
+          <a:xfrm>
+            <a:off x="6766560" y="2560320"/>
+            <a:ext cx="4572000" cy="1188720"/>
+          </a:xfrm>
+          <a:prstGeom prst="rect">
+            <a:avLst/>
+          </a:prstGeom>
+          <a:noFill/>
+        </p:spPr>
+        <p:txBody>
+          <a:bodyPr wrap="square">
+            <a:spAutoFit/>
+          </a:bodyPr>
+          <a:lstStyle/>
+          <a:p>
+            <a:pPr>
+              <a:spcBef>
+                <a:spcPts val="200"/>
+              </a:spcBef>
+              <a:spcAft>
+                <a:spcPts val="600"/>
+              </a:spcAft>
+            </a:pPr>
+            <a:r>
+              <a:rPr sz="1400">
+                <a:solidFill>
+                  <a:srgbClr val="4EC9B0"/>
+                </a:solidFill>
+                <a:latin typeface="Segoe UI"/>
+              </a:rPr>
+              <a:t>▸ </a:t>
+            </a:r>
+            <a:r>
+              <a:rPr sz="1400">
+                <a:solidFill>
+                  <a:srgbClr val="E0E0E0"/>
+                </a:solidFill>
+                <a:latin typeface="Segoe UI"/>
+              </a:rPr>
+              <a:t>File Watcher — automatic, local workspaces (Java NIO)</a:t>
+            </a:r>
+          </a:p>
+          <a:p>
+            <a:pPr>
+              <a:spcBef>
+                <a:spcPts val="200"/>
+              </a:spcBef>
+              <a:spcAft>
+                <a:spcPts val="600"/>
+              </a:spcAft>
+            </a:pPr>
+            <a:r>
+              <a:rPr sz="1400">
+                <a:solidFill>
+                  <a:srgbClr val="4EC9B0"/>
+                </a:solidFill>
+                <a:latin typeface="Segoe UI"/>
+              </a:rPr>
+              <a:t>▸ </a:t>
+            </a:r>
+            <a:r>
+              <a:rPr sz="1400">
+                <a:solidFill>
+                  <a:srgbClr val="E0E0E0"/>
+                </a:solidFill>
+                <a:latin typeface="Segoe UI"/>
+              </a:rPr>
+              <a:t>refresh_workspace — explicit, like F5 in Eclipse IDE</a:t>
+            </a:r>
+          </a:p>
+          <a:p>
+            <a:pPr>
+              <a:spcBef>
+                <a:spcPts val="200"/>
+              </a:spcBef>
+              <a:spcAft>
+                <a:spcPts val="600"/>
+              </a:spcAft>
+            </a:pPr>
+            <a:r>
+              <a:rPr sz="1400">
+                <a:solidFill>
+                  <a:srgbClr val="4EC9B0"/>
+                </a:solidFill>
+                <a:latin typeface="Segoe UI"/>
+              </a:rPr>
+              <a:t>▸ </a:t>
+            </a:r>
+            <a:r>
+              <a:rPr sz="1400">
+                <a:solidFill>
+                  <a:srgbClr val="E0E0E0"/>
+                </a:solidFill>
+                <a:latin typeface="Segoe UI"/>
+              </a:rPr>
+              <a:t>notify_file_changes — programmatic, works with remote too</a:t>
+            </a:r>
+          </a:p>
+        </p:txBody>
+      </p:sp>
+      <p:sp>
+        <p:nvSpPr>
+          <p:cNvPr id="11" name="Rounded Rectangle 10"/>
+          <p:cNvSpPr/>
+          <p:nvPr/>
+        </p:nvSpPr>
+        <p:spPr>
+          <a:xfrm>
+            <a:off x="731520" y="4114800"/>
+            <a:ext cx="10698480" cy="2560320"/>
+          </a:xfrm>
+          <a:prstGeom prst="roundRect">
+            <a:avLst/>
+          </a:prstGeom>
+          <a:solidFill>
+            <a:srgbClr val="1A3A5C"/>
+          </a:solidFill>
+          <a:ln>
+            <a:noFill/>
+          </a:ln>
+          <a:effectLst/>
+        </p:spPr>
+        <p:style>
+          <a:lnRef idx="1">
+            <a:schemeClr val="accent1"/>
+          </a:lnRef>
+          <a:fillRef idx="3">
+            <a:schemeClr val="accent1"/>
+          </a:fillRef>
+          <a:effectRef idx="2">
+            <a:schemeClr val="accent1"/>
+          </a:effectRef>
+          <a:fontRef idx="minor">
+            <a:schemeClr val="lt1"/>
+          </a:fontRef>
+        </p:style>
+        <p:txBody>
+          <a:bodyPr rtlCol="0" anchor="ctr"/>
+          <a:lstStyle/>
+          <a:p>
+            <a:pPr algn="ctr"/>
+          </a:p>
+        </p:txBody>
+      </p:sp>
+      <p:sp>
+        <p:nvSpPr>
+          <p:cNvPr id="12" name="TextBox 11"/>
+          <p:cNvSpPr txBox="1"/>
+          <p:nvPr/>
+        </p:nvSpPr>
+        <p:spPr>
+          <a:xfrm>
+            <a:off x="1097280" y="4206240"/>
+            <a:ext cx="10058400" cy="320040"/>
+          </a:xfrm>
+          <a:prstGeom prst="rect">
+            <a:avLst/>
+          </a:prstGeom>
+          <a:noFill/>
+        </p:spPr>
+        <p:txBody>
+          <a:bodyPr wrap="square">
+            <a:spAutoFit/>
+          </a:bodyPr>
+          <a:lstStyle/>
+          <a:p>
+            <a:pPr algn="l">
+              <a:defRPr sz="1600" b="1">
+                <a:solidFill>
+                  <a:srgbClr val="007ACC"/>
+                </a:solidFill>
+                <a:latin typeface="Segoe UI"/>
+              </a:defRPr>
+            </a:pPr>
+            <a:r>
+              <a:t>How it works</a:t>
+            </a:r>
+          </a:p>
+        </p:txBody>
+      </p:sp>
+      <p:sp>
+        <p:nvSpPr>
+          <p:cNvPr id="13" name="Rounded Rectangle 12"/>
+          <p:cNvSpPr/>
+          <p:nvPr/>
+        </p:nvSpPr>
+        <p:spPr>
+          <a:xfrm>
+            <a:off x="1097280" y="4663440"/>
+            <a:ext cx="2011680" cy="731520"/>
           </a:xfrm>
           <a:prstGeom prst="roundRect">
             <a:avLst/>
@@ -9021,192 +9476,122 @@
       </p:sp>
       <p:sp>
         <p:nvSpPr>
-          <p:cNvPr id="6" name="TextBox 5"/>
-          <p:cNvSpPr txBox="1"/>
-          <p:nvPr/>
-        </p:nvSpPr>
-        <p:spPr>
-          <a:xfrm>
-            <a:off x="1097280" y="2194560"/>
-            <a:ext cx="4572000" cy="457200"/>
-          </a:xfrm>
-          <a:prstGeom prst="rect">
-            <a:avLst/>
-          </a:prstGeom>
-          <a:noFill/>
-        </p:spPr>
-        <p:txBody>
-          <a:bodyPr wrap="square">
-            <a:spAutoFit/>
-          </a:bodyPr>
-          <a:lstStyle/>
-          <a:p>
-            <a:pPr algn="l">
-              <a:defRPr sz="1700" b="1">
-                <a:solidFill>
-                  <a:srgbClr val="FF8C00"/>
-                </a:solidFill>
-                <a:latin typeface="Segoe UI"/>
-              </a:defRPr>
-            </a:pPr>
-            <a:r>
-              <a:t>Known challenge:</a:t>
-            </a:r>
-            <a:br/>
-            <a:r>
-              <a:t>large project import</a:t>
-            </a:r>
-          </a:p>
-        </p:txBody>
-      </p:sp>
-      <p:sp>
-        <p:nvSpPr>
-          <p:cNvPr id="7" name="TextBox 6"/>
-          <p:cNvSpPr txBox="1"/>
-          <p:nvPr/>
-        </p:nvSpPr>
-        <p:spPr>
-          <a:xfrm>
-            <a:off x="1097280" y="2743200"/>
-            <a:ext cx="4572000" cy="3474720"/>
-          </a:xfrm>
-          <a:prstGeom prst="rect">
-            <a:avLst/>
-          </a:prstGeom>
-          <a:noFill/>
-        </p:spPr>
-        <p:txBody>
-          <a:bodyPr wrap="square">
-            <a:spAutoFit/>
-          </a:bodyPr>
-          <a:lstStyle/>
-          <a:p>
-            <a:pPr>
-              <a:spcBef>
-                <a:spcPts val="200"/>
-              </a:spcBef>
-              <a:spcAft>
-                <a:spcPts val="600"/>
-              </a:spcAft>
-            </a:pPr>
-            <a:r>
-              <a:rPr sz="1400">
-                <a:solidFill>
-                  <a:srgbClr val="007ACC"/>
-                </a:solidFill>
-                <a:latin typeface="Segoe UI"/>
-              </a:rPr>
-              <a:t>▸ </a:t>
-            </a:r>
-            <a:r>
-              <a:rPr sz="1400">
+          <p:cNvPr id="14" name="TextBox 13"/>
+          <p:cNvSpPr txBox="1"/>
+          <p:nvPr/>
+        </p:nvSpPr>
+        <p:spPr>
+          <a:xfrm>
+            <a:off x="1097280" y="4709160"/>
+            <a:ext cx="2011680" cy="320040"/>
+          </a:xfrm>
+          <a:prstGeom prst="rect">
+            <a:avLst/>
+          </a:prstGeom>
+          <a:noFill/>
+        </p:spPr>
+        <p:txBody>
+          <a:bodyPr wrap="square">
+            <a:spAutoFit/>
+          </a:bodyPr>
+          <a:lstStyle/>
+          <a:p>
+            <a:pPr algn="ctr">
+              <a:defRPr sz="1400" b="1">
                 <a:solidFill>
                   <a:srgbClr val="E0E0E0"/>
                 </a:solidFill>
                 <a:latin typeface="Segoe UI"/>
-              </a:rPr>
-              <a:t>Tested on Quarkus repo (huge codebase):</a:t>
-            </a:r>
-          </a:p>
-          <a:p>
-            <a:pPr>
-              <a:spcBef>
-                <a:spcPts val="200"/>
-              </a:spcBef>
-              <a:spcAft>
-                <a:spcPts val="600"/>
-              </a:spcAft>
-            </a:pPr>
-            <a:r>
-              <a:rPr sz="1400">
-                <a:solidFill>
-                  <a:srgbClr val="007ACC"/>
-                </a:solidFill>
-                <a:latin typeface="Segoe UI"/>
-              </a:rPr>
-              <a:t>▸ </a:t>
-            </a:r>
-            <a:r>
-              <a:rPr sz="1400">
-                <a:solidFill>
-                  <a:srgbClr val="E0E0E0"/>
-                </a:solidFill>
-                <a:latin typeface="Segoe UI"/>
-              </a:rPr>
-              <a:t>1. File scanning: each importer scans all files
-  → very slow on large repos</a:t>
-            </a:r>
-          </a:p>
-          <a:p>
-            <a:pPr>
-              <a:spcBef>
-                <a:spcPts val="200"/>
-              </a:spcBef>
-              <a:spcAft>
-                <a:spcPts val="600"/>
-              </a:spcAft>
-            </a:pPr>
-            <a:r>
-              <a:rPr sz="1400">
-                <a:solidFill>
-                  <a:srgbClr val="007ACC"/>
-                </a:solidFill>
-                <a:latin typeface="Segoe UI"/>
-              </a:rPr>
-              <a:t>▸ </a:t>
-            </a:r>
-            <a:r>
-              <a:rPr sz="1400">
-                <a:solidFill>
-                  <a:srgbClr val="E0E0E0"/>
-                </a:solidFill>
-                <a:latin typeface="Segoe UI"/>
-              </a:rPr>
-              <a:t>2. Gradle conflict: build.gradle takes over pom.xml
-  → Maven modules imported as Gradle</a:t>
-            </a:r>
-          </a:p>
-          <a:p>
-            <a:pPr>
-              <a:spcBef>
-                <a:spcPts val="200"/>
-              </a:spcBef>
-              <a:spcAft>
-                <a:spcPts val="600"/>
-              </a:spcAft>
-            </a:pPr>
-            <a:r>
-              <a:rPr sz="1400">
-                <a:solidFill>
-                  <a:srgbClr val="007ACC"/>
-                </a:solidFill>
-                <a:latin typeface="Segoe UI"/>
-              </a:rPr>
-              <a:t>▸ </a:t>
-            </a:r>
-            <a:r>
-              <a:rPr sz="1400">
-                <a:solidFill>
-                  <a:srgbClr val="E0E0E0"/>
-                </a:solidFill>
-                <a:latin typeface="Segoe UI"/>
-              </a:rPr>
-              <a:t>3. M2E import: ran 2h+, never completed
-  → JDT.LS never becomes ready</a:t>
-            </a:r>
-          </a:p>
-        </p:txBody>
-      </p:sp>
-      <p:sp>
-        <p:nvSpPr>
-          <p:cNvPr id="8" name="Rounded Rectangle 7"/>
+              </a:defRPr>
+            </a:pPr>
+            <a:r>
+              <a:t>File System</a:t>
+            </a:r>
+          </a:p>
+        </p:txBody>
+      </p:sp>
+      <p:sp>
+        <p:nvSpPr>
+          <p:cNvPr id="15" name="TextBox 14"/>
+          <p:cNvSpPr txBox="1"/>
+          <p:nvPr/>
+        </p:nvSpPr>
+        <p:spPr>
+          <a:xfrm>
+            <a:off x="1097280" y="5029200"/>
+            <a:ext cx="2011680" cy="274320"/>
+          </a:xfrm>
+          <a:prstGeom prst="rect">
+            <a:avLst/>
+          </a:prstGeom>
+          <a:noFill/>
+        </p:spPr>
+        <p:txBody>
+          <a:bodyPr wrap="square">
+            <a:spAutoFit/>
+          </a:bodyPr>
+          <a:lstStyle/>
+          <a:p>
+            <a:pPr algn="ctr">
+              <a:defRPr sz="1000" b="0">
+                <a:solidFill>
+                  <a:srgbClr val="A0A0A0"/>
+                </a:solidFill>
+                <a:latin typeface="Segoe UI"/>
+              </a:defRPr>
+            </a:pPr>
+            <a:r>
+              <a:t>*.java, pom.xml...</a:t>
+            </a:r>
+          </a:p>
+        </p:txBody>
+      </p:sp>
+      <p:sp>
+        <p:nvSpPr>
+          <p:cNvPr id="16" name="TextBox 15"/>
+          <p:cNvSpPr txBox="1"/>
+          <p:nvPr/>
+        </p:nvSpPr>
+        <p:spPr>
+          <a:xfrm>
+            <a:off x="3200400" y="4754880"/>
+            <a:ext cx="1371600" cy="365760"/>
+          </a:xfrm>
+          <a:prstGeom prst="rect">
+            <a:avLst/>
+          </a:prstGeom>
+          <a:noFill/>
+        </p:spPr>
+        <p:txBody>
+          <a:bodyPr wrap="square">
+            <a:spAutoFit/>
+          </a:bodyPr>
+          <a:lstStyle/>
+          <a:p>
+            <a:pPr algn="ctr">
+              <a:defRPr sz="1200" b="1">
+                <a:solidFill>
+                  <a:srgbClr val="DCDCAA"/>
+                </a:solidFill>
+                <a:latin typeface="Segoe UI"/>
+              </a:defRPr>
+            </a:pPr>
+            <a:r>
+              <a:t>→ events →</a:t>
+            </a:r>
+          </a:p>
+        </p:txBody>
+      </p:sp>
+      <p:sp>
+        <p:nvSpPr>
+          <p:cNvPr id="17" name="Rounded Rectangle 16"/>
           <p:cNvSpPr/>
           <p:nvPr/>
         </p:nvSpPr>
         <p:spPr>
           <a:xfrm>
-            <a:off x="6400800" y="2011680"/>
-            <a:ext cx="5029200" cy="4389120"/>
+            <a:off x="4572000" y="4663440"/>
+            <a:ext cx="2286000" cy="731520"/>
           </a:xfrm>
           <a:prstGeom prst="roundRect">
             <a:avLst/>
@@ -9243,14 +9628,238 @@
       </p:sp>
       <p:sp>
         <p:nvSpPr>
-          <p:cNvPr id="9" name="TextBox 8"/>
-          <p:cNvSpPr txBox="1"/>
-          <p:nvPr/>
-        </p:nvSpPr>
-        <p:spPr>
-          <a:xfrm>
-            <a:off x="6766560" y="2194560"/>
-            <a:ext cx="4572000" cy="457200"/>
+          <p:cNvPr id="18" name="TextBox 17"/>
+          <p:cNvSpPr txBox="1"/>
+          <p:nvPr/>
+        </p:nvSpPr>
+        <p:spPr>
+          <a:xfrm>
+            <a:off x="4572000" y="4709160"/>
+            <a:ext cx="2286000" cy="320040"/>
+          </a:xfrm>
+          <a:prstGeom prst="rect">
+            <a:avLst/>
+          </a:prstGeom>
+          <a:noFill/>
+        </p:spPr>
+        <p:txBody>
+          <a:bodyPr wrap="square">
+            <a:spAutoFit/>
+          </a:bodyPr>
+          <a:lstStyle/>
+          <a:p>
+            <a:pPr algn="ctr">
+              <a:defRPr sz="1200" b="1">
+                <a:solidFill>
+                  <a:srgbClr val="4EC9B0"/>
+                </a:solidFill>
+                <a:latin typeface="Segoe UI"/>
+              </a:defRPr>
+            </a:pPr>
+            <a:r>
+              <a:t>WorkspaceFileWatcher</a:t>
+            </a:r>
+          </a:p>
+        </p:txBody>
+      </p:sp>
+      <p:sp>
+        <p:nvSpPr>
+          <p:cNvPr id="19" name="TextBox 18"/>
+          <p:cNvSpPr txBox="1"/>
+          <p:nvPr/>
+        </p:nvSpPr>
+        <p:spPr>
+          <a:xfrm>
+            <a:off x="4572000" y="5029200"/>
+            <a:ext cx="2286000" cy="274320"/>
+          </a:xfrm>
+          <a:prstGeom prst="rect">
+            <a:avLst/>
+          </a:prstGeom>
+          <a:noFill/>
+        </p:spPr>
+        <p:txBody>
+          <a:bodyPr wrap="square">
+            <a:spAutoFit/>
+          </a:bodyPr>
+          <a:lstStyle/>
+          <a:p>
+            <a:pPr algn="ctr">
+              <a:defRPr sz="1000" b="0">
+                <a:solidFill>
+                  <a:srgbClr val="A0A0A0"/>
+                </a:solidFill>
+                <a:latin typeface="Segoe UI"/>
+              </a:defRPr>
+            </a:pPr>
+            <a:r>
+              <a:t>batch 500ms + glob filter</a:t>
+            </a:r>
+          </a:p>
+        </p:txBody>
+      </p:sp>
+      <p:sp>
+        <p:nvSpPr>
+          <p:cNvPr id="20" name="TextBox 19"/>
+          <p:cNvSpPr txBox="1"/>
+          <p:nvPr/>
+        </p:nvSpPr>
+        <p:spPr>
+          <a:xfrm>
+            <a:off x="6949440" y="4754880"/>
+            <a:ext cx="1371600" cy="365760"/>
+          </a:xfrm>
+          <a:prstGeom prst="rect">
+            <a:avLst/>
+          </a:prstGeom>
+          <a:noFill/>
+        </p:spPr>
+        <p:txBody>
+          <a:bodyPr wrap="square">
+            <a:spAutoFit/>
+          </a:bodyPr>
+          <a:lstStyle/>
+          <a:p>
+            <a:pPr algn="ctr">
+              <a:defRPr sz="1200" b="1">
+                <a:solidFill>
+                  <a:srgbClr val="DCDCAA"/>
+                </a:solidFill>
+                <a:latin typeface="Segoe UI"/>
+              </a:defRPr>
+            </a:pPr>
+            <a:r>
+              <a:t>→ LSP →</a:t>
+            </a:r>
+          </a:p>
+        </p:txBody>
+      </p:sp>
+      <p:sp>
+        <p:nvSpPr>
+          <p:cNvPr id="21" name="Rounded Rectangle 20"/>
+          <p:cNvSpPr/>
+          <p:nvPr/>
+        </p:nvSpPr>
+        <p:spPr>
+          <a:xfrm>
+            <a:off x="8229600" y="4663440"/>
+            <a:ext cx="2926080" cy="731520"/>
+          </a:xfrm>
+          <a:prstGeom prst="roundRect">
+            <a:avLst/>
+          </a:prstGeom>
+          <a:solidFill>
+            <a:srgbClr val="2D2D3D"/>
+          </a:solidFill>
+          <a:ln>
+            <a:noFill/>
+          </a:ln>
+          <a:effectLst/>
+        </p:spPr>
+        <p:style>
+          <a:lnRef idx="1">
+            <a:schemeClr val="accent1"/>
+          </a:lnRef>
+          <a:fillRef idx="3">
+            <a:schemeClr val="accent1"/>
+          </a:fillRef>
+          <a:effectRef idx="2">
+            <a:schemeClr val="accent1"/>
+          </a:effectRef>
+          <a:fontRef idx="minor">
+            <a:schemeClr val="lt1"/>
+          </a:fontRef>
+        </p:style>
+        <p:txBody>
+          <a:bodyPr rtlCol="0" anchor="ctr"/>
+          <a:lstStyle/>
+          <a:p>
+            <a:pPr algn="ctr"/>
+          </a:p>
+        </p:txBody>
+      </p:sp>
+      <p:sp>
+        <p:nvSpPr>
+          <p:cNvPr id="22" name="TextBox 21"/>
+          <p:cNvSpPr txBox="1"/>
+          <p:nvPr/>
+        </p:nvSpPr>
+        <p:spPr>
+          <a:xfrm>
+            <a:off x="8229600" y="4709160"/>
+            <a:ext cx="2926080" cy="320040"/>
+          </a:xfrm>
+          <a:prstGeom prst="rect">
+            <a:avLst/>
+          </a:prstGeom>
+          <a:noFill/>
+        </p:spPr>
+        <p:txBody>
+          <a:bodyPr wrap="square">
+            <a:spAutoFit/>
+          </a:bodyPr>
+          <a:lstStyle/>
+          <a:p>
+            <a:pPr algn="ctr">
+              <a:defRPr sz="1400" b="1">
+                <a:solidFill>
+                  <a:srgbClr val="007ACC"/>
+                </a:solidFill>
+                <a:latin typeface="Segoe UI"/>
+              </a:defRPr>
+            </a:pPr>
+            <a:r>
+              <a:t>Language Servers</a:t>
+            </a:r>
+          </a:p>
+        </p:txBody>
+      </p:sp>
+      <p:sp>
+        <p:nvSpPr>
+          <p:cNvPr id="23" name="TextBox 22"/>
+          <p:cNvSpPr txBox="1"/>
+          <p:nvPr/>
+        </p:nvSpPr>
+        <p:spPr>
+          <a:xfrm>
+            <a:off x="8229600" y="5029200"/>
+            <a:ext cx="2926080" cy="274320"/>
+          </a:xfrm>
+          <a:prstGeom prst="rect">
+            <a:avLst/>
+          </a:prstGeom>
+          <a:noFill/>
+        </p:spPr>
+        <p:txBody>
+          <a:bodyPr wrap="square">
+            <a:spAutoFit/>
+          </a:bodyPr>
+          <a:lstStyle/>
+          <a:p>
+            <a:pPr algn="ctr">
+              <a:defRPr sz="1000" b="0">
+                <a:solidFill>
+                  <a:srgbClr val="A0A0A0"/>
+                </a:solidFill>
+                <a:latin typeface="Segoe UI"/>
+              </a:defRPr>
+            </a:pPr>
+            <a:r>
+              <a:t>didChangeWatchedFiles</a:t>
+            </a:r>
+          </a:p>
+        </p:txBody>
+      </p:sp>
+      <p:sp>
+        <p:nvSpPr>
+          <p:cNvPr id="24" name="TextBox 23"/>
+          <p:cNvSpPr txBox="1"/>
+          <p:nvPr/>
+        </p:nvSpPr>
+        <p:spPr>
+          <a:xfrm>
+            <a:off x="1097280" y="5669280"/>
+            <a:ext cx="4572000" cy="822960"/>
           </a:xfrm>
           <a:prstGeom prst="rect">
             <a:avLst/>
@@ -9264,202 +9873,67 @@
           <a:lstStyle/>
           <a:p>
             <a:pPr algn="l">
-              <a:defRPr sz="2000" b="1">
-                <a:solidFill>
-                  <a:srgbClr val="007ACC"/>
-                </a:solidFill>
-                <a:latin typeface="Segoe UI"/>
-              </a:defRPr>
-            </a:pPr>
-            <a:r>
-              <a:t>Roadmap</a:t>
-            </a:r>
-          </a:p>
-        </p:txBody>
-      </p:sp>
-      <p:sp>
-        <p:nvSpPr>
-          <p:cNvPr id="10" name="TextBox 9"/>
-          <p:cNvSpPr txBox="1"/>
-          <p:nvPr/>
-        </p:nvSpPr>
-        <p:spPr>
-          <a:xfrm>
-            <a:off x="6766560" y="2743200"/>
-            <a:ext cx="4572000" cy="3474720"/>
-          </a:xfrm>
-          <a:prstGeom prst="rect">
-            <a:avLst/>
-          </a:prstGeom>
-          <a:noFill/>
-        </p:spPr>
-        <p:txBody>
-          <a:bodyPr wrap="square">
-            <a:spAutoFit/>
-          </a:bodyPr>
-          <a:lstStyle/>
-          <a:p>
-            <a:pPr>
-              <a:spcBef>
-                <a:spcPts val="200"/>
-              </a:spcBef>
-              <a:spcAft>
-                <a:spcPts val="600"/>
-              </a:spcAft>
-            </a:pPr>
-            <a:r>
-              <a:rPr sz="1400">
-                <a:solidFill>
-                  <a:srgbClr val="007ACC"/>
-                </a:solidFill>
-                <a:latin typeface="Segoe UI"/>
-              </a:rPr>
-              <a:t>▸ </a:t>
-            </a:r>
-            <a:r>
-              <a:rPr sz="1400">
-                <a:solidFill>
-                  <a:srgbClr val="E0E0E0"/>
-                </a:solidFill>
-                <a:latin typeface="Segoe UI"/>
-              </a:rPr>
-              <a:t>Fix JDT.LS import (scan, Gradle conflict)</a:t>
-            </a:r>
-          </a:p>
-          <a:p>
-            <a:pPr>
-              <a:spcBef>
-                <a:spcPts val="200"/>
-              </a:spcBef>
-              <a:spcAft>
-                <a:spcPts val="600"/>
-              </a:spcAft>
-            </a:pPr>
-            <a:r>
-              <a:rPr sz="1400">
-                <a:solidFill>
-                  <a:srgbClr val="007ACC"/>
-                </a:solidFill>
-                <a:latin typeface="Segoe UI"/>
-              </a:rPr>
-              <a:t>▸ </a:t>
-            </a:r>
-            <a:r>
-              <a:rPr sz="1400">
-                <a:solidFill>
-                  <a:srgbClr val="E0E0E0"/>
-                </a:solidFill>
-                <a:latin typeface="Segoe UI"/>
-              </a:rPr>
-              <a:t>Maven artifact caching strategy started
-  → Quarkus repo: 2h+ → 48 min</a:t>
-            </a:r>
-          </a:p>
-          <a:p>
-            <a:pPr>
-              <a:spcBef>
-                <a:spcPts val="200"/>
-              </a:spcBef>
-              <a:spcAft>
-                <a:spcPts val="600"/>
-              </a:spcAft>
-            </a:pPr>
-            <a:r>
-              <a:rPr sz="1400">
-                <a:solidFill>
-                  <a:srgbClr val="007ACC"/>
-                </a:solidFill>
-                <a:latin typeface="Segoe UI"/>
-              </a:rPr>
-              <a:t>▸ </a:t>
-            </a:r>
-            <a:r>
-              <a:rPr sz="1400">
-                <a:solidFill>
-                  <a:srgbClr val="E0E0E0"/>
-                </a:solidFill>
-                <a:latin typeface="Segoe UI"/>
-              </a:rPr>
-              <a:t>Partial / incremental M2E import</a:t>
-            </a:r>
-          </a:p>
-          <a:p>
-            <a:pPr>
-              <a:spcBef>
-                <a:spcPts val="200"/>
-              </a:spcBef>
-              <a:spcAft>
-                <a:spcPts val="600"/>
-              </a:spcAft>
-            </a:pPr>
-            <a:r>
-              <a:rPr sz="1400">
-                <a:solidFill>
-                  <a:srgbClr val="007ACC"/>
-                </a:solidFill>
-                <a:latin typeface="Segoe UI"/>
-              </a:rPr>
-              <a:t>▸ </a:t>
-            </a:r>
-            <a:r>
-              <a:rPr sz="1400">
-                <a:solidFill>
-                  <a:srgbClr val="E0E0E0"/>
-                </a:solidFill>
-                <a:latin typeface="Segoe UI"/>
-              </a:rPr>
-              <a:t>Connect to running JDT.LS in IDE
-  → reuse already-imported workspace</a:t>
-            </a:r>
-          </a:p>
-          <a:p>
-            <a:pPr>
-              <a:spcBef>
-                <a:spcPts val="200"/>
-              </a:spcBef>
-              <a:spcAft>
-                <a:spcPts val="600"/>
-              </a:spcAft>
-            </a:pPr>
-            <a:r>
-              <a:rPr sz="1400">
-                <a:solidFill>
-                  <a:srgbClr val="007ACC"/>
-                </a:solidFill>
-                <a:latin typeface="Segoe UI"/>
-              </a:rPr>
-              <a:t>▸ </a:t>
-            </a:r>
-            <a:r>
-              <a:rPr sz="1400">
-                <a:solidFill>
-                  <a:srgbClr val="E0E0E0"/>
-                </a:solidFill>
-                <a:latin typeface="Segoe UI"/>
-              </a:rPr>
-              <a:t>More language extensions</a:t>
-            </a:r>
-          </a:p>
-          <a:p>
-            <a:pPr>
-              <a:spcBef>
-                <a:spcPts val="200"/>
-              </a:spcBef>
-              <a:spcAft>
-                <a:spcPts val="600"/>
-              </a:spcAft>
-            </a:pPr>
-            <a:r>
-              <a:rPr sz="1400">
-                <a:solidFill>
-                  <a:srgbClr val="007ACC"/>
-                </a:solidFill>
-                <a:latin typeface="Segoe UI"/>
-              </a:rPr>
-              <a:t>▸ Fast mode: skip M2E for instant startup
-  → Reads pom.xml directly, resolves from ~/.m2
-  → No Maven scan, no full import
-  → ~8s (cache) vs 48s+ (M2E)</a:t>
+              <a:defRPr sz="1100" b="0">
+                <a:solidFill>
+                  <a:srgbClr val="A0A0A0"/>
+                </a:solidFill>
+                <a:latin typeface="Segoe UI"/>
+              </a:defRPr>
+            </a:pPr>
+            <a:r>
+              <a:t>Static patterns (server.json) + dynamic (registerCapability)</a:t>
+            </a:r>
+            <a:br/>
+            <a:r>
+              <a:t>Event queuing when server stopped → replay on restart</a:t>
+            </a:r>
+            <a:br/>
+            <a:r>
+              <a:t>Configurable excludes (fileWatchers.excludePatterns)</a:t>
+            </a:r>
+          </a:p>
+        </p:txBody>
+      </p:sp>
+      <p:sp>
+        <p:nvSpPr>
+          <p:cNvPr id="25" name="TextBox 24"/>
+          <p:cNvSpPr txBox="1"/>
+          <p:nvPr/>
+        </p:nvSpPr>
+        <p:spPr>
+          <a:xfrm>
+            <a:off x="6400800" y="5669280"/>
+            <a:ext cx="4572000" cy="822960"/>
+          </a:xfrm>
+          <a:prstGeom prst="rect">
+            <a:avLst/>
+          </a:prstGeom>
+          <a:noFill/>
+        </p:spPr>
+        <p:txBody>
+          <a:bodyPr wrap="square">
+            <a:spAutoFit/>
+          </a:bodyPr>
+          <a:lstStyle/>
+          <a:p>
+            <a:pPr algn="l">
+              <a:defRPr sz="1100" b="0">
+                <a:solidFill>
+                  <a:srgbClr val="A0A0A0"/>
+                </a:solidFill>
+                <a:latin typeface="Segoe UI"/>
+              </a:defRPr>
+            </a:pPr>
+            <a:r>
+              <a:t>JDT.LS: also needs project.refreshLocal() via mcp-jdtls</a:t>
+            </a:r>
+            <a:br/>
+            <a:r>
+              <a:t>→ refresh_workspace calls both LSP + server-specific refresh</a:t>
+            </a:r>
+            <a:br/>
+            <a:r>
+              <a:t>No auto-refresh on restart — explicit action by agent or admin</a:t>
             </a:r>
           </a:p>
         </p:txBody>
@@ -9564,21 +10038,57 @@
               </a:defRPr>
             </a:pPr>
             <a:r>
-              <a:t>Getting Started</a:t>
-            </a:r>
-          </a:p>
-        </p:txBody>
-      </p:sp>
-      <p:sp>
-        <p:nvSpPr>
-          <p:cNvPr id="4" name="Rounded Rectangle 3"/>
+              <a:t>Roadmap</a:t>
+            </a:r>
+          </a:p>
+        </p:txBody>
+      </p:sp>
+      <p:sp>
+        <p:nvSpPr>
+          <p:cNvPr id="4" name="TextBox 3"/>
+          <p:cNvSpPr txBox="1"/>
+          <p:nvPr/>
+        </p:nvSpPr>
+        <p:spPr>
+          <a:xfrm>
+            <a:off x="731520" y="1280160"/>
+            <a:ext cx="10058400" cy="548640"/>
+          </a:xfrm>
+          <a:prstGeom prst="rect">
+            <a:avLst/>
+          </a:prstGeom>
+          <a:noFill/>
+        </p:spPr>
+        <p:txBody>
+          <a:bodyPr wrap="square">
+            <a:spAutoFit/>
+          </a:bodyPr>
+          <a:lstStyle/>
+          <a:p>
+            <a:pPr algn="l">
+              <a:defRPr sz="1800" b="0">
+                <a:solidFill>
+                  <a:srgbClr val="A0A0A0"/>
+                </a:solidFill>
+                <a:latin typeface="Segoe UI"/>
+              </a:defRPr>
+            </a:pPr>
+            <a:r>
+              <a:t>Scaling to large Java projects and beyond</a:t>
+            </a:r>
+          </a:p>
+        </p:txBody>
+      </p:sp>
+      <p:sp>
+        <p:nvSpPr>
+          <p:cNvPr id="5" name="Rounded Rectangle 4"/>
           <p:cNvSpPr/>
           <p:nvPr/>
         </p:nvSpPr>
         <p:spPr>
           <a:xfrm>
             <a:off x="731520" y="2011680"/>
-            <a:ext cx="10515600" cy="1828800"/>
+            <a:ext cx="5029200" cy="4389120"/>
           </a:xfrm>
           <a:prstGeom prst="roundRect">
             <a:avLst/>
@@ -9615,14 +10125,14 @@
       </p:sp>
       <p:sp>
         <p:nvSpPr>
-          <p:cNvPr id="5" name="TextBox 4"/>
-          <p:cNvSpPr txBox="1"/>
-          <p:nvPr/>
-        </p:nvSpPr>
-        <p:spPr>
-          <a:xfrm>
-            <a:off x="1097280" y="2103120"/>
-            <a:ext cx="10058400" cy="365760"/>
+          <p:cNvPr id="6" name="TextBox 5"/>
+          <p:cNvSpPr txBox="1"/>
+          <p:nvPr/>
+        </p:nvSpPr>
+        <p:spPr>
+          <a:xfrm>
+            <a:off x="1097280" y="2194560"/>
+            <a:ext cx="4572000" cy="457200"/>
           </a:xfrm>
           <a:prstGeom prst="rect">
             <a:avLst/>
@@ -9636,73 +10146,171 @@
           <a:lstStyle/>
           <a:p>
             <a:pPr algn="l">
-              <a:defRPr sz="1800" b="1">
+              <a:defRPr sz="1700" b="1">
+                <a:solidFill>
+                  <a:srgbClr val="FF8C00"/>
+                </a:solidFill>
+                <a:latin typeface="Segoe UI"/>
+              </a:defRPr>
+            </a:pPr>
+            <a:r>
+              <a:t>Known challenge:</a:t>
+            </a:r>
+            <a:br/>
+            <a:r>
+              <a:t>large project import</a:t>
+            </a:r>
+          </a:p>
+        </p:txBody>
+      </p:sp>
+      <p:sp>
+        <p:nvSpPr>
+          <p:cNvPr id="7" name="TextBox 6"/>
+          <p:cNvSpPr txBox="1"/>
+          <p:nvPr/>
+        </p:nvSpPr>
+        <p:spPr>
+          <a:xfrm>
+            <a:off x="1097280" y="2743200"/>
+            <a:ext cx="4572000" cy="3474720"/>
+          </a:xfrm>
+          <a:prstGeom prst="rect">
+            <a:avLst/>
+          </a:prstGeom>
+          <a:noFill/>
+        </p:spPr>
+        <p:txBody>
+          <a:bodyPr wrap="square">
+            <a:spAutoFit/>
+          </a:bodyPr>
+          <a:lstStyle/>
+          <a:p>
+            <a:pPr>
+              <a:spcBef>
+                <a:spcPts val="200"/>
+              </a:spcBef>
+              <a:spcAft>
+                <a:spcPts val="600"/>
+              </a:spcAft>
+            </a:pPr>
+            <a:r>
+              <a:rPr sz="1400">
                 <a:solidFill>
                   <a:srgbClr val="007ACC"/>
                 </a:solidFill>
                 <a:latin typeface="Segoe UI"/>
-              </a:defRPr>
-            </a:pPr>
-            <a:r>
-              <a:t>1. Clone and start MCP Language Tools</a:t>
-            </a:r>
-          </a:p>
-        </p:txBody>
-      </p:sp>
-      <p:sp>
-        <p:nvSpPr>
-          <p:cNvPr id="6" name="TextBox 5"/>
-          <p:cNvSpPr txBox="1"/>
-          <p:nvPr/>
-        </p:nvSpPr>
-        <p:spPr>
-          <a:xfrm>
-            <a:off x="1097280" y="2560320"/>
-            <a:ext cx="10058400" cy="914400"/>
-          </a:xfrm>
-          <a:prstGeom prst="rect">
-            <a:avLst/>
-          </a:prstGeom>
-          <a:noFill/>
-        </p:spPr>
-        <p:txBody>
-          <a:bodyPr wrap="square">
-            <a:spAutoFit/>
-          </a:bodyPr>
-          <a:lstStyle/>
-          <a:p>
-            <a:pPr algn="l">
-              <a:defRPr sz="1600" b="0">
-                <a:solidFill>
-                  <a:srgbClr val="DCDCAA"/>
-                </a:solidFill>
-                <a:latin typeface="Consolas"/>
-              </a:defRPr>
-            </a:pPr>
-            <a:r>
-              <a:t>git clone https://github.com/angelozerr/mcp-languagetools</a:t>
-            </a:r>
-            <a:br/>
-            <a:r>
-              <a:t>cd mcp-languagetools</a:t>
-            </a:r>
-            <a:br/>
-            <a:r>
-              <a:t>./mvnw quarkus:dev -f dev/pom.xml</a:t>
-            </a:r>
-          </a:p>
-        </p:txBody>
-      </p:sp>
-      <p:sp>
-        <p:nvSpPr>
-          <p:cNvPr id="7" name="Rounded Rectangle 6"/>
+              </a:rPr>
+              <a:t>▸ </a:t>
+            </a:r>
+            <a:r>
+              <a:rPr sz="1400">
+                <a:solidFill>
+                  <a:srgbClr val="E0E0E0"/>
+                </a:solidFill>
+                <a:latin typeface="Segoe UI"/>
+              </a:rPr>
+              <a:t>Tested on Quarkus repo (huge codebase):</a:t>
+            </a:r>
+          </a:p>
+          <a:p>
+            <a:pPr>
+              <a:spcBef>
+                <a:spcPts val="200"/>
+              </a:spcBef>
+              <a:spcAft>
+                <a:spcPts val="600"/>
+              </a:spcAft>
+            </a:pPr>
+            <a:r>
+              <a:rPr sz="1400">
+                <a:solidFill>
+                  <a:srgbClr val="007ACC"/>
+                </a:solidFill>
+                <a:latin typeface="Segoe UI"/>
+              </a:rPr>
+              <a:t>▸ </a:t>
+            </a:r>
+            <a:r>
+              <a:rPr sz="1400">
+                <a:solidFill>
+                  <a:srgbClr val="E0E0E0"/>
+                </a:solidFill>
+                <a:latin typeface="Segoe UI"/>
+              </a:rPr>
+              <a:t>1. File scanning: each importer scans all files
+  → very slow on large repos</a:t>
+            </a:r>
+          </a:p>
+          <a:p>
+            <a:pPr>
+              <a:spcBef>
+                <a:spcPts val="200"/>
+              </a:spcBef>
+              <a:spcAft>
+                <a:spcPts val="600"/>
+              </a:spcAft>
+            </a:pPr>
+            <a:r>
+              <a:rPr sz="1400">
+                <a:solidFill>
+                  <a:srgbClr val="007ACC"/>
+                </a:solidFill>
+                <a:latin typeface="Segoe UI"/>
+              </a:rPr>
+              <a:t>▸ </a:t>
+            </a:r>
+            <a:r>
+              <a:rPr sz="1400">
+                <a:solidFill>
+                  <a:srgbClr val="E0E0E0"/>
+                </a:solidFill>
+                <a:latin typeface="Segoe UI"/>
+              </a:rPr>
+              <a:t>2. Gradle conflict: build.gradle takes over pom.xml
+  → Maven modules imported as Gradle</a:t>
+            </a:r>
+          </a:p>
+          <a:p>
+            <a:pPr>
+              <a:spcBef>
+                <a:spcPts val="200"/>
+              </a:spcBef>
+              <a:spcAft>
+                <a:spcPts val="600"/>
+              </a:spcAft>
+            </a:pPr>
+            <a:r>
+              <a:rPr sz="1400">
+                <a:solidFill>
+                  <a:srgbClr val="007ACC"/>
+                </a:solidFill>
+                <a:latin typeface="Segoe UI"/>
+              </a:rPr>
+              <a:t>▸ </a:t>
+            </a:r>
+            <a:r>
+              <a:rPr sz="1400">
+                <a:solidFill>
+                  <a:srgbClr val="E0E0E0"/>
+                </a:solidFill>
+                <a:latin typeface="Segoe UI"/>
+              </a:rPr>
+              <a:t>3. M2E import: ran 2h+, never completed
+  → JDT.LS never becomes ready</a:t>
+            </a:r>
+          </a:p>
+        </p:txBody>
+      </p:sp>
+      <p:sp>
+        <p:nvSpPr>
+          <p:cNvPr id="8" name="Rounded Rectangle 7"/>
           <p:cNvSpPr/>
           <p:nvPr/>
         </p:nvSpPr>
         <p:spPr>
           <a:xfrm>
-            <a:off x="731520" y="3657600"/>
-            <a:ext cx="10515600" cy="1645920"/>
+            <a:off x="6400800" y="2011680"/>
+            <a:ext cx="5029200" cy="4389120"/>
           </a:xfrm>
           <a:prstGeom prst="roundRect">
             <a:avLst/>
@@ -9739,14 +10347,14 @@
       </p:sp>
       <p:sp>
         <p:nvSpPr>
-          <p:cNvPr id="8" name="TextBox 7"/>
-          <p:cNvSpPr txBox="1"/>
-          <p:nvPr/>
-        </p:nvSpPr>
-        <p:spPr>
-          <a:xfrm>
-            <a:off x="1097280" y="3749039"/>
-            <a:ext cx="10058400" cy="365760"/>
+          <p:cNvPr id="9" name="TextBox 8"/>
+          <p:cNvSpPr txBox="1"/>
+          <p:nvPr/>
+        </p:nvSpPr>
+        <p:spPr>
+          <a:xfrm>
+            <a:off x="6766560" y="2194560"/>
+            <a:ext cx="4572000" cy="457200"/>
           </a:xfrm>
           <a:prstGeom prst="rect">
             <a:avLst/>
@@ -9760,7 +10368,7 @@
           <a:lstStyle/>
           <a:p>
             <a:pPr algn="l">
-              <a:defRPr sz="1800" b="1">
+              <a:defRPr sz="2000" b="1">
                 <a:solidFill>
                   <a:srgbClr val="007ACC"/>
                 </a:solidFill>
@@ -9768,139 +10376,172 @@
               </a:defRPr>
             </a:pPr>
             <a:r>
-              <a:t>2. Configure your MCP client (Claude Code, Bob...)</a:t>
-            </a:r>
-          </a:p>
-        </p:txBody>
-      </p:sp>
-      <p:sp>
-        <p:nvSpPr>
-          <p:cNvPr id="9" name="TextBox 8"/>
-          <p:cNvSpPr txBox="1"/>
-          <p:nvPr/>
-        </p:nvSpPr>
-        <p:spPr>
-          <a:xfrm>
-            <a:off x="1097280" y="4206240"/>
-            <a:ext cx="10058400" cy="1097280"/>
-          </a:xfrm>
-          <a:prstGeom prst="rect">
-            <a:avLst/>
-          </a:prstGeom>
-          <a:noFill/>
-        </p:spPr>
-        <p:txBody>
-          <a:bodyPr wrap="square">
-            <a:spAutoFit/>
-          </a:bodyPr>
-          <a:lstStyle/>
-          <a:p>
-            <a:pPr algn="l">
-              <a:defRPr sz="1600" b="0">
-                <a:solidFill>
-                  <a:srgbClr val="DCDCAA"/>
-                </a:solidFill>
-                <a:latin typeface="Consolas"/>
-              </a:defRPr>
-            </a:pPr>
-            <a:r>
-              <a:t>{</a:t>
-            </a:r>
-            <a:br/>
-            <a:r>
-              <a:t>  "mcpServers": {</a:t>
-            </a:r>
-            <a:br/>
-            <a:r>
-              <a:t>    "mcp-languagetools": { "url": "http://localhost:7654/mcp" }</a:t>
-            </a:r>
-            <a:br/>
-            <a:r>
-              <a:t>  }</a:t>
-            </a:r>
-            <a:br/>
-            <a:r>
-              <a:t>}</a:t>
-            </a:r>
-          </a:p>
-        </p:txBody>
-      </p:sp>
-      <p:sp>
-        <p:nvSpPr>
-          <p:cNvPr id="10" name="Rounded Rectangle 9"/>
-          <p:cNvSpPr/>
-          <p:nvPr/>
-        </p:nvSpPr>
-        <p:spPr>
-          <a:xfrm>
-            <a:off x="731520" y="5577840"/>
-            <a:ext cx="10515600" cy="731520"/>
-          </a:xfrm>
-          <a:prstGeom prst="roundRect">
-            <a:avLst/>
-          </a:prstGeom>
-          <a:solidFill>
-            <a:srgbClr val="2D2D3D"/>
-          </a:solidFill>
-          <a:ln>
-            <a:noFill/>
-          </a:ln>
-          <a:effectLst/>
-        </p:spPr>
-        <p:style>
-          <a:lnRef idx="1">
-            <a:schemeClr val="accent1"/>
-          </a:lnRef>
-          <a:fillRef idx="3">
-            <a:schemeClr val="accent1"/>
-          </a:fillRef>
-          <a:effectRef idx="2">
-            <a:schemeClr val="accent1"/>
-          </a:effectRef>
-          <a:fontRef idx="minor">
-            <a:schemeClr val="lt1"/>
-          </a:fontRef>
-        </p:style>
-        <p:txBody>
-          <a:bodyPr rtlCol="0" anchor="ctr"/>
-          <a:lstStyle/>
-          <a:p>
-            <a:pPr algn="ctr"/>
-          </a:p>
-        </p:txBody>
-      </p:sp>
-      <p:sp>
-        <p:nvSpPr>
-          <p:cNvPr id="11" name="TextBox 10"/>
-          <p:cNvSpPr txBox="1"/>
-          <p:nvPr/>
-        </p:nvSpPr>
-        <p:spPr>
-          <a:xfrm>
-            <a:off x="1097280" y="5669280"/>
-            <a:ext cx="10058400" cy="365760"/>
-          </a:xfrm>
-          <a:prstGeom prst="rect">
-            <a:avLst/>
-          </a:prstGeom>
-          <a:noFill/>
-        </p:spPr>
-        <p:txBody>
-          <a:bodyPr wrap="square">
-            <a:spAutoFit/>
-          </a:bodyPr>
-          <a:lstStyle/>
-          <a:p>
-            <a:pPr algn="l">
-              <a:defRPr sz="1800" b="1">
+              <a:t>Roadmap</a:t>
+            </a:r>
+          </a:p>
+        </p:txBody>
+      </p:sp>
+      <p:sp>
+        <p:nvSpPr>
+          <p:cNvPr id="10" name="TextBox 9"/>
+          <p:cNvSpPr txBox="1"/>
+          <p:nvPr/>
+        </p:nvSpPr>
+        <p:spPr>
+          <a:xfrm>
+            <a:off x="6766560" y="2743200"/>
+            <a:ext cx="4572000" cy="3474720"/>
+          </a:xfrm>
+          <a:prstGeom prst="rect">
+            <a:avLst/>
+          </a:prstGeom>
+          <a:noFill/>
+        </p:spPr>
+        <p:txBody>
+          <a:bodyPr wrap="square">
+            <a:spAutoFit/>
+          </a:bodyPr>
+          <a:lstStyle/>
+          <a:p>
+            <a:pPr>
+              <a:spcBef>
+                <a:spcPts val="200"/>
+              </a:spcBef>
+              <a:spcAft>
+                <a:spcPts val="600"/>
+              </a:spcAft>
+            </a:pPr>
+            <a:r>
+              <a:rPr sz="1400">
                 <a:solidFill>
                   <a:srgbClr val="007ACC"/>
                 </a:solidFill>
                 <a:latin typeface="Segoe UI"/>
-              </a:defRPr>
-            </a:pPr>
-            <a:r>
-              <a:t>3. Ask your AI assistant to work on Java code!</a:t>
+              </a:rPr>
+              <a:t>▸ </a:t>
+            </a:r>
+            <a:r>
+              <a:rPr sz="1400">
+                <a:solidFill>
+                  <a:srgbClr val="E0E0E0"/>
+                </a:solidFill>
+                <a:latin typeface="Segoe UI"/>
+              </a:rPr>
+              <a:t>Fix JDT.LS import (scan, Gradle conflict)</a:t>
+            </a:r>
+          </a:p>
+          <a:p>
+            <a:pPr>
+              <a:spcBef>
+                <a:spcPts val="200"/>
+              </a:spcBef>
+              <a:spcAft>
+                <a:spcPts val="600"/>
+              </a:spcAft>
+            </a:pPr>
+            <a:r>
+              <a:rPr sz="1400">
+                <a:solidFill>
+                  <a:srgbClr val="007ACC"/>
+                </a:solidFill>
+                <a:latin typeface="Segoe UI"/>
+              </a:rPr>
+              <a:t>▸ </a:t>
+            </a:r>
+            <a:r>
+              <a:rPr sz="1400">
+                <a:solidFill>
+                  <a:srgbClr val="E0E0E0"/>
+                </a:solidFill>
+                <a:latin typeface="Segoe UI"/>
+              </a:rPr>
+              <a:t>Maven artifact caching strategy started
+  → Quarkus repo: 2h+ → 48 min</a:t>
+            </a:r>
+          </a:p>
+          <a:p>
+            <a:pPr>
+              <a:spcBef>
+                <a:spcPts val="200"/>
+              </a:spcBef>
+              <a:spcAft>
+                <a:spcPts val="600"/>
+              </a:spcAft>
+            </a:pPr>
+            <a:r>
+              <a:rPr sz="1400">
+                <a:solidFill>
+                  <a:srgbClr val="007ACC"/>
+                </a:solidFill>
+                <a:latin typeface="Segoe UI"/>
+              </a:rPr>
+              <a:t>▸ </a:t>
+            </a:r>
+            <a:r>
+              <a:rPr sz="1400">
+                <a:solidFill>
+                  <a:srgbClr val="E0E0E0"/>
+                </a:solidFill>
+                <a:latin typeface="Segoe UI"/>
+              </a:rPr>
+              <a:t>Partial / incremental M2E import</a:t>
+            </a:r>
+          </a:p>
+          <a:p>
+            <a:pPr>
+              <a:spcBef>
+                <a:spcPts val="200"/>
+              </a:spcBef>
+              <a:spcAft>
+                <a:spcPts val="600"/>
+              </a:spcAft>
+            </a:pPr>
+            <a:r>
+              <a:rPr sz="1400">
+                <a:solidFill>
+                  <a:srgbClr val="007ACC"/>
+                </a:solidFill>
+                <a:latin typeface="Segoe UI"/>
+              </a:rPr>
+              <a:t>▸ </a:t>
+            </a:r>
+            <a:r>
+              <a:rPr sz="1400">
+                <a:solidFill>
+                  <a:srgbClr val="E0E0E0"/>
+                </a:solidFill>
+                <a:latin typeface="Segoe UI"/>
+              </a:rPr>
+              <a:t>Connect to running JDT.LS in IDE
+  → reuse already-imported workspace</a:t>
+            </a:r>
+          </a:p>
+          <a:p>
+            <a:pPr>
+              <a:spcBef>
+                <a:spcPts val="200"/>
+              </a:spcBef>
+              <a:spcAft>
+                <a:spcPts val="600"/>
+              </a:spcAft>
+            </a:pPr>
+            <a:r>
+              <a:rPr sz="1400">
+                <a:solidFill>
+                  <a:srgbClr val="007ACC"/>
+                </a:solidFill>
+                <a:latin typeface="Segoe UI"/>
+              </a:rPr>
+              <a:t>▸ </a:t>
+            </a:r>
+            <a:r>
+              <a:rPr sz="1400">
+                <a:solidFill>
+                  <a:srgbClr val="E0E0E0"/>
+                </a:solidFill>
+                <a:latin typeface="Segoe UI"/>
+              </a:rPr>
+              <a:t>More language extensions</a:t>
             </a:r>
           </a:p>
         </p:txBody>
@@ -9933,6 +10574,447 @@
       <p:grpSpPr/>
       <p:sp>
         <p:nvSpPr>
+          <p:cNvPr id="2" name="Rectangle 1"/>
+          <p:cNvSpPr/>
+          <p:nvPr/>
+        </p:nvSpPr>
+        <p:spPr>
+          <a:xfrm>
+            <a:off x="731520" y="548640"/>
+            <a:ext cx="1828800" cy="38100"/>
+          </a:xfrm>
+          <a:prstGeom prst="rect">
+            <a:avLst/>
+          </a:prstGeom>
+          <a:solidFill>
+            <a:srgbClr val="007ACC"/>
+          </a:solidFill>
+          <a:ln>
+            <a:noFill/>
+          </a:ln>
+        </p:spPr>
+        <p:style>
+          <a:lnRef idx="1">
+            <a:schemeClr val="accent1"/>
+          </a:lnRef>
+          <a:fillRef idx="3">
+            <a:schemeClr val="accent1"/>
+          </a:fillRef>
+          <a:effectRef idx="2">
+            <a:schemeClr val="accent1"/>
+          </a:effectRef>
+          <a:fontRef idx="minor">
+            <a:schemeClr val="lt1"/>
+          </a:fontRef>
+        </p:style>
+        <p:txBody>
+          <a:bodyPr rtlCol="0" anchor="ctr"/>
+          <a:lstStyle/>
+          <a:p>
+            <a:pPr algn="ctr"/>
+          </a:p>
+        </p:txBody>
+      </p:sp>
+      <p:sp>
+        <p:nvSpPr>
+          <p:cNvPr id="3" name="TextBox 2"/>
+          <p:cNvSpPr txBox="1"/>
+          <p:nvPr/>
+        </p:nvSpPr>
+        <p:spPr>
+          <a:xfrm>
+            <a:off x="731520" y="640080"/>
+            <a:ext cx="10058400" cy="914400"/>
+          </a:xfrm>
+          <a:prstGeom prst="rect">
+            <a:avLst/>
+          </a:prstGeom>
+          <a:noFill/>
+        </p:spPr>
+        <p:txBody>
+          <a:bodyPr wrap="square">
+            <a:spAutoFit/>
+          </a:bodyPr>
+          <a:lstStyle/>
+          <a:p>
+            <a:pPr algn="l">
+              <a:defRPr sz="3600" b="1">
+                <a:solidFill>
+                  <a:srgbClr val="E0E0E0"/>
+                </a:solidFill>
+                <a:latin typeface="Segoe UI"/>
+              </a:defRPr>
+            </a:pPr>
+            <a:r>
+              <a:t>Getting Started</a:t>
+            </a:r>
+          </a:p>
+        </p:txBody>
+      </p:sp>
+      <p:sp>
+        <p:nvSpPr>
+          <p:cNvPr id="4" name="Rounded Rectangle 3"/>
+          <p:cNvSpPr/>
+          <p:nvPr/>
+        </p:nvSpPr>
+        <p:spPr>
+          <a:xfrm>
+            <a:off x="731520" y="2011680"/>
+            <a:ext cx="10515600" cy="1828800"/>
+          </a:xfrm>
+          <a:prstGeom prst="roundRect">
+            <a:avLst/>
+          </a:prstGeom>
+          <a:solidFill>
+            <a:srgbClr val="2D2D3D"/>
+          </a:solidFill>
+          <a:ln>
+            <a:noFill/>
+          </a:ln>
+          <a:effectLst/>
+        </p:spPr>
+        <p:style>
+          <a:lnRef idx="1">
+            <a:schemeClr val="accent1"/>
+          </a:lnRef>
+          <a:fillRef idx="3">
+            <a:schemeClr val="accent1"/>
+          </a:fillRef>
+          <a:effectRef idx="2">
+            <a:schemeClr val="accent1"/>
+          </a:effectRef>
+          <a:fontRef idx="minor">
+            <a:schemeClr val="lt1"/>
+          </a:fontRef>
+        </p:style>
+        <p:txBody>
+          <a:bodyPr rtlCol="0" anchor="ctr"/>
+          <a:lstStyle/>
+          <a:p>
+            <a:pPr algn="ctr"/>
+          </a:p>
+        </p:txBody>
+      </p:sp>
+      <p:sp>
+        <p:nvSpPr>
+          <p:cNvPr id="5" name="TextBox 4"/>
+          <p:cNvSpPr txBox="1"/>
+          <p:nvPr/>
+        </p:nvSpPr>
+        <p:spPr>
+          <a:xfrm>
+            <a:off x="1097280" y="2103120"/>
+            <a:ext cx="10058400" cy="365760"/>
+          </a:xfrm>
+          <a:prstGeom prst="rect">
+            <a:avLst/>
+          </a:prstGeom>
+          <a:noFill/>
+        </p:spPr>
+        <p:txBody>
+          <a:bodyPr wrap="square">
+            <a:spAutoFit/>
+          </a:bodyPr>
+          <a:lstStyle/>
+          <a:p>
+            <a:pPr algn="l">
+              <a:defRPr sz="1800" b="1">
+                <a:solidFill>
+                  <a:srgbClr val="007ACC"/>
+                </a:solidFill>
+                <a:latin typeface="Segoe UI"/>
+              </a:defRPr>
+            </a:pPr>
+            <a:r>
+              <a:t>1. Clone and start MCP Language Tools</a:t>
+            </a:r>
+          </a:p>
+        </p:txBody>
+      </p:sp>
+      <p:sp>
+        <p:nvSpPr>
+          <p:cNvPr id="6" name="TextBox 5"/>
+          <p:cNvSpPr txBox="1"/>
+          <p:nvPr/>
+        </p:nvSpPr>
+        <p:spPr>
+          <a:xfrm>
+            <a:off x="1097280" y="2560320"/>
+            <a:ext cx="10058400" cy="914400"/>
+          </a:xfrm>
+          <a:prstGeom prst="rect">
+            <a:avLst/>
+          </a:prstGeom>
+          <a:noFill/>
+        </p:spPr>
+        <p:txBody>
+          <a:bodyPr wrap="square">
+            <a:spAutoFit/>
+          </a:bodyPr>
+          <a:lstStyle/>
+          <a:p>
+            <a:pPr algn="l">
+              <a:defRPr sz="1600" b="0">
+                <a:solidFill>
+                  <a:srgbClr val="DCDCAA"/>
+                </a:solidFill>
+                <a:latin typeface="Consolas"/>
+              </a:defRPr>
+            </a:pPr>
+            <a:r>
+              <a:t>git clone https://github.com/angelozerr/mcp-languagetools</a:t>
+            </a:r>
+            <a:br/>
+            <a:r>
+              <a:t>cd mcp-languagetools</a:t>
+            </a:r>
+            <a:br/>
+            <a:r>
+              <a:t>./mvnw quarkus:dev -f dev/pom.xml</a:t>
+            </a:r>
+          </a:p>
+        </p:txBody>
+      </p:sp>
+      <p:sp>
+        <p:nvSpPr>
+          <p:cNvPr id="7" name="Rounded Rectangle 6"/>
+          <p:cNvSpPr/>
+          <p:nvPr/>
+        </p:nvSpPr>
+        <p:spPr>
+          <a:xfrm>
+            <a:off x="731520" y="3657600"/>
+            <a:ext cx="10515600" cy="1645920"/>
+          </a:xfrm>
+          <a:prstGeom prst="roundRect">
+            <a:avLst/>
+          </a:prstGeom>
+          <a:solidFill>
+            <a:srgbClr val="2D2D3D"/>
+          </a:solidFill>
+          <a:ln>
+            <a:noFill/>
+          </a:ln>
+          <a:effectLst/>
+        </p:spPr>
+        <p:style>
+          <a:lnRef idx="1">
+            <a:schemeClr val="accent1"/>
+          </a:lnRef>
+          <a:fillRef idx="3">
+            <a:schemeClr val="accent1"/>
+          </a:fillRef>
+          <a:effectRef idx="2">
+            <a:schemeClr val="accent1"/>
+          </a:effectRef>
+          <a:fontRef idx="minor">
+            <a:schemeClr val="lt1"/>
+          </a:fontRef>
+        </p:style>
+        <p:txBody>
+          <a:bodyPr rtlCol="0" anchor="ctr"/>
+          <a:lstStyle/>
+          <a:p>
+            <a:pPr algn="ctr"/>
+          </a:p>
+        </p:txBody>
+      </p:sp>
+      <p:sp>
+        <p:nvSpPr>
+          <p:cNvPr id="8" name="TextBox 7"/>
+          <p:cNvSpPr txBox="1"/>
+          <p:nvPr/>
+        </p:nvSpPr>
+        <p:spPr>
+          <a:xfrm>
+            <a:off x="1097280" y="3749039"/>
+            <a:ext cx="10058400" cy="365760"/>
+          </a:xfrm>
+          <a:prstGeom prst="rect">
+            <a:avLst/>
+          </a:prstGeom>
+          <a:noFill/>
+        </p:spPr>
+        <p:txBody>
+          <a:bodyPr wrap="square">
+            <a:spAutoFit/>
+          </a:bodyPr>
+          <a:lstStyle/>
+          <a:p>
+            <a:pPr algn="l">
+              <a:defRPr sz="1800" b="1">
+                <a:solidFill>
+                  <a:srgbClr val="007ACC"/>
+                </a:solidFill>
+                <a:latin typeface="Segoe UI"/>
+              </a:defRPr>
+            </a:pPr>
+            <a:r>
+              <a:t>2. Configure your MCP client (Claude Code, Bob...)</a:t>
+            </a:r>
+          </a:p>
+        </p:txBody>
+      </p:sp>
+      <p:sp>
+        <p:nvSpPr>
+          <p:cNvPr id="9" name="TextBox 8"/>
+          <p:cNvSpPr txBox="1"/>
+          <p:nvPr/>
+        </p:nvSpPr>
+        <p:spPr>
+          <a:xfrm>
+            <a:off x="1097280" y="4206240"/>
+            <a:ext cx="10058400" cy="1097280"/>
+          </a:xfrm>
+          <a:prstGeom prst="rect">
+            <a:avLst/>
+          </a:prstGeom>
+          <a:noFill/>
+        </p:spPr>
+        <p:txBody>
+          <a:bodyPr wrap="square">
+            <a:spAutoFit/>
+          </a:bodyPr>
+          <a:lstStyle/>
+          <a:p>
+            <a:pPr algn="l">
+              <a:defRPr sz="1600" b="0">
+                <a:solidFill>
+                  <a:srgbClr val="DCDCAA"/>
+                </a:solidFill>
+                <a:latin typeface="Consolas"/>
+              </a:defRPr>
+            </a:pPr>
+            <a:r>
+              <a:t>{</a:t>
+            </a:r>
+            <a:br/>
+            <a:r>
+              <a:t>  "mcpServers": {</a:t>
+            </a:r>
+            <a:br/>
+            <a:r>
+              <a:t>    "mcp-languagetools": { "url": "http://localhost:7654/mcp" }</a:t>
+            </a:r>
+            <a:br/>
+            <a:r>
+              <a:t>  }</a:t>
+            </a:r>
+            <a:br/>
+            <a:r>
+              <a:t>}</a:t>
+            </a:r>
+          </a:p>
+        </p:txBody>
+      </p:sp>
+      <p:sp>
+        <p:nvSpPr>
+          <p:cNvPr id="10" name="Rounded Rectangle 9"/>
+          <p:cNvSpPr/>
+          <p:nvPr/>
+        </p:nvSpPr>
+        <p:spPr>
+          <a:xfrm>
+            <a:off x="731520" y="5577840"/>
+            <a:ext cx="10515600" cy="731520"/>
+          </a:xfrm>
+          <a:prstGeom prst="roundRect">
+            <a:avLst/>
+          </a:prstGeom>
+          <a:solidFill>
+            <a:srgbClr val="2D2D3D"/>
+          </a:solidFill>
+          <a:ln>
+            <a:noFill/>
+          </a:ln>
+          <a:effectLst/>
+        </p:spPr>
+        <p:style>
+          <a:lnRef idx="1">
+            <a:schemeClr val="accent1"/>
+          </a:lnRef>
+          <a:fillRef idx="3">
+            <a:schemeClr val="accent1"/>
+          </a:fillRef>
+          <a:effectRef idx="2">
+            <a:schemeClr val="accent1"/>
+          </a:effectRef>
+          <a:fontRef idx="minor">
+            <a:schemeClr val="lt1"/>
+          </a:fontRef>
+        </p:style>
+        <p:txBody>
+          <a:bodyPr rtlCol="0" anchor="ctr"/>
+          <a:lstStyle/>
+          <a:p>
+            <a:pPr algn="ctr"/>
+          </a:p>
+        </p:txBody>
+      </p:sp>
+      <p:sp>
+        <p:nvSpPr>
+          <p:cNvPr id="11" name="TextBox 10"/>
+          <p:cNvSpPr txBox="1"/>
+          <p:nvPr/>
+        </p:nvSpPr>
+        <p:spPr>
+          <a:xfrm>
+            <a:off x="1097280" y="5669280"/>
+            <a:ext cx="10058400" cy="365760"/>
+          </a:xfrm>
+          <a:prstGeom prst="rect">
+            <a:avLst/>
+          </a:prstGeom>
+          <a:noFill/>
+        </p:spPr>
+        <p:txBody>
+          <a:bodyPr wrap="square">
+            <a:spAutoFit/>
+          </a:bodyPr>
+          <a:lstStyle/>
+          <a:p>
+            <a:pPr algn="l">
+              <a:defRPr sz="1800" b="1">
+                <a:solidFill>
+                  <a:srgbClr val="007ACC"/>
+                </a:solidFill>
+                <a:latin typeface="Segoe UI"/>
+              </a:defRPr>
+            </a:pPr>
+            <a:r>
+              <a:t>3. Ask your AI assistant to work on Java code!</a:t>
+            </a:r>
+          </a:p>
+        </p:txBody>
+      </p:sp>
+    </p:spTree>
+  </p:cSld>
+  <p:clrMapOvr>
+    <a:masterClrMapping/>
+  </p:clrMapOvr>
+</p:sld>
+</file>
+
+<file path=ppt/slides/slide24.xml><?xml version="1.0" encoding="utf-8"?>
+<p:sld xmlns:a="http://schemas.openxmlformats.org/drawingml/2006/main" xmlns:p="http://schemas.openxmlformats.org/presentationml/2006/main" xmlns:r="http://schemas.openxmlformats.org/officeDocument/2006/relationships">
+  <p:cSld>
+    <p:bg>
+      <p:bgPr>
+        <a:solidFill>
+          <a:srgbClr val="1E1E2E"/>
+        </a:solidFill>
+        <a:effectLst/>
+      </p:bgPr>
+    </p:bg>
+    <p:spTree>
+      <p:nvGrpSpPr>
+        <p:cNvPr id="1" name=""/>
+        <p:cNvGrpSpPr/>
+        <p:nvPr/>
+      </p:nvGrpSpPr>
+      <p:grpSpPr/>
+      <p:sp>
+        <p:nvSpPr>
           <p:cNvPr id="2" name="TextBox 1"/>
           <p:cNvSpPr txBox="1"/>
           <p:nvPr/>
@@ -11534,7 +12616,7 @@
               </a:defRPr>
             </a:pPr>
             <a:r>
-              <a:t>135+ MCP Tools</a:t>
+              <a:t>110+ MCP Tools</a:t>
             </a:r>
           </a:p>
         </p:txBody>
@@ -11794,7 +12876,7 @@
               </a:defRPr>
             </a:pPr>
             <a:r>
-              <a:t>79 Java tools + mcp-jdtls</a:t>
+              <a:t>80 Java tools + mcp-jdtls</a:t>
             </a:r>
           </a:p>
         </p:txBody>
@@ -12194,15 +13276,15 @@
               </a:defRPr>
             </a:pPr>
             <a:r>
-              <a:t>contributes: bundles, classpath,bindRequest/Notification79 Java tools via mcp-jdtls</a:t>
+              <a:t>contributes: bundles, classpath,</a:t>
             </a:r>
             <a:br/>
             <a:r>
-              <a:t/>
+              <a:t>bindRequest/Notification</a:t>
             </a:r>
             <a:br/>
             <a:r>
-              <a:t/>
+              <a:t>80 Java tools via mcp-jdtls</a:t>
             </a:r>
           </a:p>
         </p:txBody>
@@ -12318,15 +13400,15 @@
               </a:defRPr>
             </a:pPr>
             <a:r>
-              <a:t>19+ language extensionsAdd any LSP/DAP serverAdmin console</a:t>
+              <a:t>18+ language extensions</a:t>
             </a:r>
             <a:br/>
             <a:r>
-              <a:t/>
+              <a:t>Add any LSP/DAP server</a:t>
             </a:r>
             <a:br/>
             <a:r>
-              <a:t/>
+              <a:t>Admin console</a:t>
             </a:r>
           </a:p>
         </p:txBody>
@@ -13997,7 +15079,7 @@
               </a:defRPr>
             </a:pPr>
             <a:r>
-              <a:t>Java: 79 Specialized MCP Tools</a:t>
+              <a:t>Java: 80 Specialized MCP Tools</a:t>
             </a:r>
           </a:p>
         </p:txBody>
@@ -17385,7 +18467,7 @@
               </a:defRPr>
             </a:pPr>
             <a:r>
-              <a:t>26 DAP Tools</a:t>
+              <a:t>24 DAP Tools</a:t>
             </a:r>
           </a:p>
         </p:txBody>
@@ -17661,44 +18743,6 @@
                 <a:latin typeface="Segoe UI"/>
               </a:rPr>
               <a:t>get_debug_statistics — session summary</a:t>
-            </a:r>
-          </a:p>
-          <a:p>
-            <a:pPr>
-              <a:spcBef>
-                <a:spcPts val="200"/>
-              </a:spcBef>
-              <a:spcAft>
-                <a:spcPts val="600"/>
-              </a:spcAft>
-            </a:pPr>
-            <a:r>
-              <a:rPr sz="1500">
-                <a:solidFill>
-                  <a:srgbClr val="007ACC"/>
-                </a:solidFill>
-                <a:latin typeface="Segoe UI"/>
-              </a:rPr>
-              <a:t>▸ disassemble — assembly-level inspection</a:t>
-            </a:r>
-          </a:p>
-          <a:p>
-            <a:pPr>
-              <a:spcBef>
-                <a:spcPts val="200"/>
-              </a:spcBef>
-              <a:spcAft>
-                <a:spcPts val="600"/>
-              </a:spcAft>
-            </a:pPr>
-            <a:r>
-              <a:rPr sz="1500">
-                <a:solidFill>
-                  <a:srgbClr val="007ACC"/>
-                </a:solidFill>
-                <a:latin typeface="Segoe UI"/>
-              </a:rPr>
-              <a:t>▸ set/remove_instruction_breakpoint</a:t>
             </a:r>
           </a:p>
         </p:txBody>

</xml_diff>

<commit_message>
Initialize missing LSP tools
Signed-off-by: azerr <azerr@redhat.com>
</commit_message>
<xml_diff>
--- a/presentation/MCP_LanguageTools.pptx
+++ b/presentation/MCP_LanguageTools.pptx
@@ -1,5 +1,76 @@
 
-<file path=ppt/presentation.xml><?xml version="1.0" encoding="utf-8"?>
+<file path=docProps\app.xml><?xml version="1.0" encoding="utf-8"?>
+<Properties xmlns="http://schemas.openxmlformats.org/officeDocument/2006/extended-properties" xmlns:vt="http://schemas.openxmlformats.org/officeDocument/2006/docPropsVTypes">
+  <TotalTime>1</TotalTime>
+  <Words>0</Words>
+  <Application>Microsoft Macintosh PowerPoint</Application>
+  <PresentationFormat>On-screen Show (4:3)</PresentationFormat>
+  <Paragraphs>0</Paragraphs>
+  <Slides>0</Slides>
+  <Notes>0</Notes>
+  <HiddenSlides>0</HiddenSlides>
+  <MMClips>0</MMClips>
+  <ScaleCrop>false</ScaleCrop>
+  <HeadingPairs>
+    <vt:vector size="4" baseType="variant">
+      <vt:variant>
+        <vt:lpstr>Theme</vt:lpstr>
+      </vt:variant>
+      <vt:variant>
+        <vt:i4>1</vt:i4>
+      </vt:variant>
+      <vt:variant>
+        <vt:lpstr>Slide Titles</vt:lpstr>
+      </vt:variant>
+      <vt:variant>
+        <vt:i4>0</vt:i4>
+      </vt:variant>
+    </vt:vector>
+  </HeadingPairs>
+  <TitlesOfParts>
+    <vt:vector size="1" baseType="lpstr">
+      <vt:lpstr>Office Theme</vt:lpstr>
+    </vt:vector>
+  </TitlesOfParts>
+  <Manager/>
+  <Company/>
+  <LinksUpToDate>false</LinksUpToDate>
+  <SharedDoc>false</SharedDoc>
+  <HyperlinkBase/>
+  <HyperlinksChanged>false</HyperlinksChanged>
+  <AppVersion>14.0000</AppVersion>
+</Properties>
+</file>
+
+<file path=docProps\core.xml><?xml version="1.0" encoding="utf-8"?>
+<cp:coreProperties xmlns:cp="http://schemas.openxmlformats.org/package/2006/metadata/core-properties" xmlns:dc="http://purl.org/dc/elements/1.1/" xmlns:dcterms="http://purl.org/dc/terms/" xmlns:dcmitype="http://purl.org/dc/dcmitype/" xmlns:xsi="http://www.w3.org/2001/XMLSchema-instance">
+  <dc:title/>
+  <dc:subject/>
+  <dc:creator/>
+  <cp:keywords/>
+  <dc:description>generated using python-pptx</dc:description>
+  <cp:lastModifiedBy>Steve Canny</cp:lastModifiedBy>
+  <cp:revision>1</cp:revision>
+  <dcterms:created xsi:type="dcterms:W3CDTF">2013-01-27T09:14:16Z</dcterms:created>
+  <dcterms:modified xsi:type="dcterms:W3CDTF">2013-01-27T09:15:58Z</dcterms:modified>
+  <cp:category/>
+</cp:coreProperties>
+</file>
+
+<file path=ppt\presProps.xml><?xml version="1.0" encoding="utf-8"?>
+<p:presentationPr xmlns:a="http://schemas.openxmlformats.org/drawingml/2006/main" xmlns:r="http://schemas.openxmlformats.org/officeDocument/2006/relationships" xmlns:p="http://schemas.openxmlformats.org/presentationml/2006/main">
+  <p:extLst>
+    <p:ext uri="{E76CE94A-603C-4142-B9EB-6D1370010A27}">
+      <p14:discardImageEditData xmlns:p14="http://schemas.microsoft.com/office/powerpoint/2010/main" val="0"/>
+    </p:ext>
+    <p:ext uri="{D31A062A-798A-4329-ABDD-BBA856620510}">
+      <p14:defaultImageDpi xmlns:p14="http://schemas.microsoft.com/office/powerpoint/2010/main" val="0"/>
+    </p:ext>
+  </p:extLst>
+</p:presentationPr>
+</file>
+
+<file path=ppt\presentation.xml><?xml version="1.0" encoding="utf-8"?>
 <p:presentation xmlns:a="http://schemas.openxmlformats.org/drawingml/2006/main" xmlns:r="http://schemas.openxmlformats.org/officeDocument/2006/relationships" xmlns:p="http://schemas.openxmlformats.org/presentationml/2006/main" saveSubsetFonts="1" autoCompressPictures="0">
   <p:sldMasterIdLst>
     <p:sldMasterId id="2147483648" r:id="rId1"/>
@@ -130,7 +201,7 @@
 </p:presentation>
 </file>
 
-<file path=ppt/slideLayouts/slideLayout1.xml><?xml version="1.0" encoding="utf-8"?>
+<file path=ppt\slideLayouts\slideLayout1.xml><?xml version="1.0" encoding="utf-8"?>
 <p:sldLayout xmlns:a="http://schemas.openxmlformats.org/drawingml/2006/main" xmlns:r="http://schemas.openxmlformats.org/officeDocument/2006/relationships" xmlns:p="http://schemas.openxmlformats.org/presentationml/2006/main" type="title" preserve="1">
   <p:cSld name="Title Slide">
     <p:spTree>
@@ -372,7 +443,7 @@
 </p:sldLayout>
 </file>
 
-<file path=ppt/slideLayouts/slideLayout10.xml><?xml version="1.0" encoding="utf-8"?>
+<file path=ppt\slideLayouts\slideLayout10.xml><?xml version="1.0" encoding="utf-8"?>
 <p:sldLayout xmlns:a="http://schemas.openxmlformats.org/drawingml/2006/main" xmlns:r="http://schemas.openxmlformats.org/officeDocument/2006/relationships" xmlns:p="http://schemas.openxmlformats.org/presentationml/2006/main" type="vertTx" preserve="1">
   <p:cSld name="Title and Vertical Text">
     <p:spTree>
@@ -542,7 +613,7 @@
 </p:sldLayout>
 </file>
 
-<file path=ppt/slideLayouts/slideLayout11.xml><?xml version="1.0" encoding="utf-8"?>
+<file path=ppt\slideLayouts\slideLayout11.xml><?xml version="1.0" encoding="utf-8"?>
 <p:sldLayout xmlns:a="http://schemas.openxmlformats.org/drawingml/2006/main" xmlns:r="http://schemas.openxmlformats.org/officeDocument/2006/relationships" xmlns:p="http://schemas.openxmlformats.org/presentationml/2006/main" type="vertTitleAndTx" preserve="1">
   <p:cSld name="Vertical Title and Text">
     <p:spTree>
@@ -722,7 +793,7 @@
 </p:sldLayout>
 </file>
 
-<file path=ppt/slideLayouts/slideLayout2.xml><?xml version="1.0" encoding="utf-8"?>
+<file path=ppt\slideLayouts\slideLayout2.xml><?xml version="1.0" encoding="utf-8"?>
 <p:sldLayout xmlns:a="http://schemas.openxmlformats.org/drawingml/2006/main" xmlns:r="http://schemas.openxmlformats.org/officeDocument/2006/relationships" xmlns:p="http://schemas.openxmlformats.org/presentationml/2006/main" type="obj" preserve="1">
   <p:cSld name="Title and Content">
     <p:spTree>
@@ -892,7 +963,7 @@
 </p:sldLayout>
 </file>
 
-<file path=ppt/slideLayouts/slideLayout3.xml><?xml version="1.0" encoding="utf-8"?>
+<file path=ppt\slideLayouts\slideLayout3.xml><?xml version="1.0" encoding="utf-8"?>
 <p:sldLayout xmlns:a="http://schemas.openxmlformats.org/drawingml/2006/main" xmlns:r="http://schemas.openxmlformats.org/officeDocument/2006/relationships" xmlns:p="http://schemas.openxmlformats.org/presentationml/2006/main" type="secHead" preserve="1">
   <p:cSld name="Section Header">
     <p:spTree>
@@ -1138,7 +1209,7 @@
 </p:sldLayout>
 </file>
 
-<file path=ppt/slideLayouts/slideLayout4.xml><?xml version="1.0" encoding="utf-8"?>
+<file path=ppt\slideLayouts\slideLayout4.xml><?xml version="1.0" encoding="utf-8"?>
 <p:sldLayout xmlns:a="http://schemas.openxmlformats.org/drawingml/2006/main" xmlns:r="http://schemas.openxmlformats.org/officeDocument/2006/relationships" xmlns:p="http://schemas.openxmlformats.org/presentationml/2006/main" type="twoObj" preserve="1">
   <p:cSld name="Two Content">
     <p:spTree>
@@ -1426,7 +1497,7 @@
 </p:sldLayout>
 </file>
 
-<file path=ppt/slideLayouts/slideLayout5.xml><?xml version="1.0" encoding="utf-8"?>
+<file path=ppt\slideLayouts\slideLayout5.xml><?xml version="1.0" encoding="utf-8"?>
 <p:sldLayout xmlns:a="http://schemas.openxmlformats.org/drawingml/2006/main" xmlns:r="http://schemas.openxmlformats.org/officeDocument/2006/relationships" xmlns:p="http://schemas.openxmlformats.org/presentationml/2006/main" type="twoTxTwoObj" preserve="1">
   <p:cSld name="Comparison">
     <p:spTree>
@@ -1848,7 +1919,7 @@
 </p:sldLayout>
 </file>
 
-<file path=ppt/slideLayouts/slideLayout6.xml><?xml version="1.0" encoding="utf-8"?>
+<file path=ppt\slideLayouts\slideLayout6.xml><?xml version="1.0" encoding="utf-8"?>
 <p:sldLayout xmlns:a="http://schemas.openxmlformats.org/drawingml/2006/main" xmlns:r="http://schemas.openxmlformats.org/officeDocument/2006/relationships" xmlns:p="http://schemas.openxmlformats.org/presentationml/2006/main" type="titleOnly" preserve="1">
   <p:cSld name="Title Only">
     <p:spTree>
@@ -1966,7 +2037,7 @@
 </p:sldLayout>
 </file>
 
-<file path=ppt/slideLayouts/slideLayout7.xml><?xml version="1.0" encoding="utf-8"?>
+<file path=ppt\slideLayouts\slideLayout7.xml><?xml version="1.0" encoding="utf-8"?>
 <p:sldLayout xmlns:a="http://schemas.openxmlformats.org/drawingml/2006/main" xmlns:r="http://schemas.openxmlformats.org/officeDocument/2006/relationships" xmlns:p="http://schemas.openxmlformats.org/presentationml/2006/main" type="blank" preserve="1">
   <p:cSld name="Blank">
     <p:spTree>
@@ -2061,7 +2132,7 @@
 </p:sldLayout>
 </file>
 
-<file path=ppt/slideLayouts/slideLayout8.xml><?xml version="1.0" encoding="utf-8"?>
+<file path=ppt\slideLayouts\slideLayout8.xml><?xml version="1.0" encoding="utf-8"?>
 <p:sldLayout xmlns:a="http://schemas.openxmlformats.org/drawingml/2006/main" xmlns:r="http://schemas.openxmlformats.org/officeDocument/2006/relationships" xmlns:p="http://schemas.openxmlformats.org/presentationml/2006/main" type="objTx" preserve="1">
   <p:cSld name="Content with Caption">
     <p:spTree>
@@ -2338,7 +2409,7 @@
 </p:sldLayout>
 </file>
 
-<file path=ppt/slideLayouts/slideLayout9.xml><?xml version="1.0" encoding="utf-8"?>
+<file path=ppt\slideLayouts\slideLayout9.xml><?xml version="1.0" encoding="utf-8"?>
 <p:sldLayout xmlns:a="http://schemas.openxmlformats.org/drawingml/2006/main" xmlns:r="http://schemas.openxmlformats.org/officeDocument/2006/relationships" xmlns:p="http://schemas.openxmlformats.org/presentationml/2006/main" type="picTx" preserve="1">
   <p:cSld name="Picture with Caption">
     <p:spTree>
@@ -2591,7 +2662,7 @@
 </p:sldLayout>
 </file>
 
-<file path=ppt/slideMasters/slideMaster1.xml><?xml version="1.0" encoding="utf-8"?>
+<file path=ppt\slideMasters\slideMaster1.xml><?xml version="1.0" encoding="utf-8"?>
 <p:sldMaster xmlns:a="http://schemas.openxmlformats.org/drawingml/2006/main" xmlns:r="http://schemas.openxmlformats.org/officeDocument/2006/relationships" xmlns:p="http://schemas.openxmlformats.org/presentationml/2006/main">
   <p:cSld>
     <p:bg>
@@ -3101,7 +3172,7 @@
 </p:sldMaster>
 </file>
 
-<file path=ppt/slides/slide1.xml><?xml version="1.0" encoding="utf-8"?>
+<file path=ppt\slides\slide1.xml><?xml version="1.0" encoding="utf-8"?>
 <p:sld xmlns:a="http://schemas.openxmlformats.org/drawingml/2006/main" xmlns:p="http://schemas.openxmlformats.org/presentationml/2006/main" xmlns:r="http://schemas.openxmlformats.org/officeDocument/2006/relationships">
   <p:cSld>
     <p:bg>
@@ -3318,7 +3389,7 @@
 </p:sld>
 </file>
 
-<file path=ppt/slides/slide10.xml><?xml version="1.0" encoding="utf-8"?>
+<file path=ppt\slides\slide10.xml><?xml version="1.0" encoding="utf-8"?>
 <p:sld xmlns:a="http://schemas.openxmlformats.org/drawingml/2006/main" xmlns:p="http://schemas.openxmlformats.org/presentationml/2006/main" xmlns:r="http://schemas.openxmlformats.org/officeDocument/2006/relationships">
   <p:cSld>
     <p:bg>
@@ -3691,7 +3762,7 @@
 </p:sld>
 </file>
 
-<file path=ppt/slides/slide11.xml><?xml version="1.0" encoding="utf-8"?>
+<file path=ppt\slides\slide11.xml><?xml version="1.0" encoding="utf-8"?>
 <p:sld xmlns:a="http://schemas.openxmlformats.org/drawingml/2006/main" xmlns:p="http://schemas.openxmlformats.org/presentationml/2006/main" xmlns:r="http://schemas.openxmlformats.org/officeDocument/2006/relationships">
   <p:cSld>
     <p:bg>
@@ -5135,7 +5206,7 @@
 </p:sld>
 </file>
 
-<file path=ppt/slides/slide12.xml><?xml version="1.0" encoding="utf-8"?>
+<file path=ppt\slides\slide12.xml><?xml version="1.0" encoding="utf-8"?>
 <p:sld xmlns:a="http://schemas.openxmlformats.org/drawingml/2006/main" xmlns:p="http://schemas.openxmlformats.org/presentationml/2006/main" xmlns:r="http://schemas.openxmlformats.org/officeDocument/2006/relationships">
   <p:cSld>
     <p:bg>
@@ -5800,7 +5871,7 @@
 </p:sld>
 </file>
 
-<file path=ppt/slides/slide13.xml><?xml version="1.0" encoding="utf-8"?>
+<file path=ppt\slides\slide13.xml><?xml version="1.0" encoding="utf-8"?>
 <p:sld xmlns:a="http://schemas.openxmlformats.org/drawingml/2006/main" xmlns:p="http://schemas.openxmlformats.org/presentationml/2006/main" xmlns:r="http://schemas.openxmlformats.org/officeDocument/2006/relationships">
   <p:cSld>
     <p:bg>
@@ -5965,7 +6036,7 @@
 </p:sld>
 </file>
 
-<file path=ppt/slides/slide14.xml><?xml version="1.0" encoding="utf-8"?>
+<file path=ppt\slides\slide14.xml><?xml version="1.0" encoding="utf-8"?>
 <p:sld xmlns:a="http://schemas.openxmlformats.org/drawingml/2006/main" xmlns:p="http://schemas.openxmlformats.org/presentationml/2006/main" xmlns:r="http://schemas.openxmlformats.org/officeDocument/2006/relationships">
   <p:cSld>
     <p:bg>
@@ -6698,7 +6769,7 @@
 </p:sld>
 </file>
 
-<file path=ppt/slides/slide15.xml><?xml version="1.0" encoding="utf-8"?>
+<file path=ppt\slides\slide15.xml><?xml version="1.0" encoding="utf-8"?>
 <p:sld xmlns:a="http://schemas.openxmlformats.org/drawingml/2006/main" xmlns:p="http://schemas.openxmlformats.org/presentationml/2006/main" xmlns:r="http://schemas.openxmlformats.org/officeDocument/2006/relationships">
   <p:cSld>
     <p:bg>
@@ -6863,7 +6934,7 @@
 </p:sld>
 </file>
 
-<file path=ppt/slides/slide16.xml><?xml version="1.0" encoding="utf-8"?>
+<file path=ppt\slides\slide16.xml><?xml version="1.0" encoding="utf-8"?>
 <p:sld xmlns:a="http://schemas.openxmlformats.org/drawingml/2006/main" xmlns:p="http://schemas.openxmlformats.org/presentationml/2006/main" xmlns:r="http://schemas.openxmlformats.org/officeDocument/2006/relationships">
   <p:cSld>
     <p:bg>
@@ -7028,7 +7099,7 @@
 </p:sld>
 </file>
 
-<file path=ppt/slides/slide17.xml><?xml version="1.0" encoding="utf-8"?>
+<file path=ppt\slides\slide17.xml><?xml version="1.0" encoding="utf-8"?>
 <p:sld xmlns:a="http://schemas.openxmlformats.org/drawingml/2006/main" xmlns:p="http://schemas.openxmlformats.org/presentationml/2006/main" xmlns:r="http://schemas.openxmlformats.org/officeDocument/2006/relationships">
   <p:cSld>
     <p:bg>
@@ -7193,7 +7264,7 @@
 </p:sld>
 </file>
 
-<file path=ppt/slides/slide18.xml><?xml version="1.0" encoding="utf-8"?>
+<file path=ppt\slides\slide18.xml><?xml version="1.0" encoding="utf-8"?>
 <p:sld xmlns:a="http://schemas.openxmlformats.org/drawingml/2006/main" xmlns:p="http://schemas.openxmlformats.org/presentationml/2006/main" xmlns:r="http://schemas.openxmlformats.org/officeDocument/2006/relationships">
   <p:cSld>
     <p:bg>
@@ -7358,7 +7429,7 @@
 </p:sld>
 </file>
 
-<file path=ppt/slides/slide19.xml><?xml version="1.0" encoding="utf-8"?>
+<file path=ppt\slides\slide19.xml><?xml version="1.0" encoding="utf-8"?>
 <p:sld xmlns:a="http://schemas.openxmlformats.org/drawingml/2006/main" xmlns:p="http://schemas.openxmlformats.org/presentationml/2006/main" xmlns:r="http://schemas.openxmlformats.org/officeDocument/2006/relationships">
   <p:cSld>
     <p:bg>
@@ -7523,7 +7594,7 @@
 </p:sld>
 </file>
 
-<file path=ppt/slides/slide2.xml><?xml version="1.0" encoding="utf-8"?>
+<file path=ppt\slides\slide2.xml><?xml version="1.0" encoding="utf-8"?>
 <p:sld xmlns:a="http://schemas.openxmlformats.org/drawingml/2006/main" xmlns:p="http://schemas.openxmlformats.org/presentationml/2006/main" xmlns:r="http://schemas.openxmlformats.org/officeDocument/2006/relationships">
   <p:cSld>
     <p:bg>
@@ -8679,7 +8750,7 @@
 </p:sld>
 </file>
 
-<file path=ppt/slides/slide20.xml><?xml version="1.0" encoding="utf-8"?>
+<file path=ppt\slides\slide20.xml><?xml version="1.0" encoding="utf-8"?>
 <p:sld xmlns:a="http://schemas.openxmlformats.org/drawingml/2006/main" xmlns:p="http://schemas.openxmlformats.org/presentationml/2006/main" xmlns:r="http://schemas.openxmlformats.org/officeDocument/2006/relationships">
   <p:cSld>
     <p:bg>
@@ -8844,7 +8915,7 @@
 </p:sld>
 </file>
 
-<file path=ppt/slides/slide21.xml><?xml version="1.0" encoding="utf-8"?>
+<file path=ppt\slides\slide21.xml><?xml version="1.0" encoding="utf-8"?>
 <p:sld xmlns:a="http://schemas.openxmlformats.org/drawingml/2006/main" xmlns:p="http://schemas.openxmlformats.org/presentationml/2006/main" xmlns:r="http://schemas.openxmlformats.org/officeDocument/2006/relationships">
   <p:cSld>
     <p:bg>
@@ -9948,7 +10019,7 @@
 </p:sld>
 </file>
 
-<file path=ppt/slides/slide22.xml><?xml version="1.0" encoding="utf-8"?>
+<file path=ppt\slides\slide22.xml><?xml version="1.0" encoding="utf-8"?>
 <p:sld xmlns:a="http://schemas.openxmlformats.org/drawingml/2006/main" xmlns:p="http://schemas.openxmlformats.org/presentationml/2006/main" xmlns:r="http://schemas.openxmlformats.org/officeDocument/2006/relationships">
   <p:cSld>
     <p:bg>
@@ -10556,7 +10627,7 @@
 </p:sld>
 </file>
 
-<file path=ppt/slides/slide23.xml><?xml version="1.0" encoding="utf-8"?>
+<file path=ppt\slides\slide23.xml><?xml version="1.0" encoding="utf-8"?>
 <p:sld xmlns:a="http://schemas.openxmlformats.org/drawingml/2006/main" xmlns:p="http://schemas.openxmlformats.org/presentationml/2006/main" xmlns:r="http://schemas.openxmlformats.org/officeDocument/2006/relationships">
   <p:cSld>
     <p:bg>
@@ -10997,7 +11068,7 @@
 </p:sld>
 </file>
 
-<file path=ppt/slides/slide24.xml><?xml version="1.0" encoding="utf-8"?>
+<file path=ppt\slides\slide24.xml><?xml version="1.0" encoding="utf-8"?>
 <p:sld xmlns:a="http://schemas.openxmlformats.org/drawingml/2006/main" xmlns:p="http://schemas.openxmlformats.org/presentationml/2006/main" xmlns:r="http://schemas.openxmlformats.org/officeDocument/2006/relationships">
   <p:cSld>
     <p:bg>
@@ -11271,7 +11342,7 @@
 </p:sld>
 </file>
 
-<file path=ppt/slides/slide3.xml><?xml version="1.0" encoding="utf-8"?>
+<file path=ppt\slides\slide3.xml><?xml version="1.0" encoding="utf-8"?>
 <p:sld xmlns:a="http://schemas.openxmlformats.org/drawingml/2006/main" xmlns:p="http://schemas.openxmlformats.org/presentationml/2006/main" xmlns:r="http://schemas.openxmlformats.org/officeDocument/2006/relationships">
   <p:cSld>
     <p:bg>
@@ -12222,7 +12293,7 @@
 </p:sld>
 </file>
 
-<file path=ppt/slides/slide4.xml><?xml version="1.0" encoding="utf-8"?>
+<file path=ppt\slides\slide4.xml><?xml version="1.0" encoding="utf-8"?>
 <p:sld xmlns:a="http://schemas.openxmlformats.org/drawingml/2006/main" xmlns:p="http://schemas.openxmlformats.org/presentationml/2006/main" xmlns:r="http://schemas.openxmlformats.org/officeDocument/2006/relationships">
   <p:cSld>
     <p:bg>
@@ -12618,7 +12689,7 @@
               </a:defRPr>
             </a:pPr>
             <a:r>
-              <a:t>110+ MCP Tools</a:t>
+              <a:t>120+ MCP Tools</a:t>
             </a:r>
           </a:p>
         </p:txBody>
@@ -13547,7 +13618,7 @@
 </p:sld>
 </file>
 
-<file path=ppt/slides/slide5.xml><?xml version="1.0" encoding="utf-8"?>
+<file path=ppt\slides\slide5.xml><?xml version="1.0" encoding="utf-8"?>
 <p:sld xmlns:a="http://schemas.openxmlformats.org/drawingml/2006/main" xmlns:p="http://schemas.openxmlformats.org/presentationml/2006/main" xmlns:r="http://schemas.openxmlformats.org/officeDocument/2006/relationships">
   <p:cSld>
     <p:bg>
@@ -14336,7 +14407,7 @@
 </p:sld>
 </file>
 
-<file path=ppt/slides/slide6.xml><?xml version="1.0" encoding="utf-8"?>
+<file path=ppt\slides\slide6.xml><?xml version="1.0" encoding="utf-8"?>
 <p:sld xmlns:a="http://schemas.openxmlformats.org/drawingml/2006/main" xmlns:p="http://schemas.openxmlformats.org/presentationml/2006/main" xmlns:r="http://schemas.openxmlformats.org/officeDocument/2006/relationships">
   <p:cSld>
     <p:bg>
@@ -14989,7 +15060,7 @@
 </p:sld>
 </file>
 
-<file path=ppt/slides/slide7.xml><?xml version="1.0" encoding="utf-8"?>
+<file path=ppt\slides\slide7.xml><?xml version="1.0" encoding="utf-8"?>
 <p:sld xmlns:a="http://schemas.openxmlformats.org/drawingml/2006/main" xmlns:p="http://schemas.openxmlformats.org/presentationml/2006/main" xmlns:r="http://schemas.openxmlformats.org/officeDocument/2006/relationships">
   <p:cSld>
     <p:bg>
@@ -17262,7 +17333,7 @@
 </p:sld>
 </file>
 
-<file path=ppt/slides/slide8.xml><?xml version="1.0" encoding="utf-8"?>
+<file path=ppt\slides\slide8.xml><?xml version="1.0" encoding="utf-8"?>
 <p:sld xmlns:a="http://schemas.openxmlformats.org/drawingml/2006/main" xmlns:p="http://schemas.openxmlformats.org/presentationml/2006/main" xmlns:r="http://schemas.openxmlformats.org/officeDocument/2006/relationships">
   <p:cSld>
     <p:bg>
@@ -18261,7 +18332,7 @@
 </p:sld>
 </file>
 
-<file path=ppt/slides/slide9.xml><?xml version="1.0" encoding="utf-8"?>
+<file path=ppt\slides\slide9.xml><?xml version="1.0" encoding="utf-8"?>
 <p:sld xmlns:a="http://schemas.openxmlformats.org/drawingml/2006/main" xmlns:p="http://schemas.openxmlformats.org/presentationml/2006/main" xmlns:r="http://schemas.openxmlformats.org/officeDocument/2006/relationships">
   <p:cSld>
     <p:bg>
@@ -18911,7 +18982,11 @@
 </p:sld>
 </file>
 
-<file path=ppt/theme/theme1.xml><?xml version="1.0" encoding="utf-8"?>
+<file path=ppt\tableStyles.xml><?xml version="1.0" encoding="utf-8"?>
+<a:tblStyleLst xmlns:a="http://schemas.openxmlformats.org/drawingml/2006/main" def="{5C22544A-7EE6-4342-B048-85BDC9FD1C3A}"/>
+</file>
+
+<file path=ppt\theme\theme1.xml><?xml version="1.0" encoding="utf-8"?>
 <a:theme xmlns:a="http://schemas.openxmlformats.org/drawingml/2006/main" name="Office Theme">
   <a:themeElements>
     <a:clrScheme name="Office">
@@ -19229,4 +19304,38 @@
   </a:objectDefaults>
   <a:extraClrSchemeLst/>
 </a:theme>
+</file>
+
+<file path=ppt\viewProps.xml><?xml version="1.0" encoding="utf-8"?>
+<p:viewPr xmlns:a="http://schemas.openxmlformats.org/drawingml/2006/main" xmlns:r="http://schemas.openxmlformats.org/officeDocument/2006/relationships" xmlns:p="http://schemas.openxmlformats.org/presentationml/2006/main" lastView="sldThumbnailView">
+  <p:normalViewPr>
+    <p:restoredLeft sz="15620"/>
+    <p:restoredTop sz="94660"/>
+  </p:normalViewPr>
+  <p:slideViewPr>
+    <p:cSldViewPr snapToGrid="0" snapToObjects="1">
+      <p:cViewPr varScale="1">
+        <p:scale>
+          <a:sx n="124" d="100"/>
+          <a:sy n="124" d="100"/>
+        </p:scale>
+        <p:origin x="-1512" y="-112"/>
+      </p:cViewPr>
+      <p:guideLst>
+        <p:guide orient="horz" pos="2160"/>
+        <p:guide pos="2880"/>
+      </p:guideLst>
+    </p:cSldViewPr>
+  </p:slideViewPr>
+  <p:notesTextViewPr>
+    <p:cViewPr>
+      <p:scale>
+        <a:sx n="100" d="100"/>
+        <a:sy n="100" d="100"/>
+      </p:scale>
+      <p:origin x="0" y="0"/>
+    </p:cViewPr>
+  </p:notesTextViewPr>
+  <p:gridSpacing cx="76200" cy="76200"/>
+</p:viewPr>
 </file>
</xml_diff>

<commit_message>
Add mvnw clean install
Signed-off-by: azerr <azerr@redhat.com>
</commit_message>
<xml_diff>
--- a/presentation/MCP_LanguageTools.pptx
+++ b/presentation/MCP_LanguageTools.pptx
@@ -10730,7 +10730,7 @@
               </a:defRPr>
             </a:pPr>
             <a:r>
-              <a:t>1. Clone and start MCP Language Tools</a:t>
+              <a:t>1. Clone, build, and start MCP Language Tools</a:t>
             </a:r>
           </a:p>
         </p:txBody>
@@ -10758,7 +10758,7 @@
           <a:lstStyle/>
           <a:p>
             <a:pPr algn="l">
-              <a:defRPr sz="1600" b="0">
+              <a:defRPr sz="1400" b="0">
                 <a:solidFill>
                   <a:srgbClr val="DCDCAA"/>
                 </a:solidFill>
@@ -10771,6 +10771,10 @@
             <a:br/>
             <a:r>
               <a:t>cd mcp-languagetools</a:t>
+            </a:r>
+            <a:br/>
+            <a:r>
+              <a:t>./mvnw clean install -DskipTests</a:t>
             </a:r>
             <a:br/>
             <a:r>

</xml_diff>